<commit_message>
Support any AI provider through one setting, and correct the validation slide
AI_PROVIDER now selects between mock, anthropic, openai, deepseek, gemini,
groq and a locally running ollama. Anthropic uses its own library; the other
five share the OpenAI protocol, so one function serves all of them with a
different address and model name. Nothing outside ai.py changes.

Every path was exercised: mock and ollama returned answers, and the paid
providers each reached their own endpoint and were correctly rejected for a
missing key. render.yaml declares every provider key with sync:false.

The input-validation slide now states that the malformed request must be
sent from /docs. The web page cannot send it, because its reading input is
type=number, so testing it there appears to show nothing happening.

Co-Authored-By: Claude Opus 5 <noreply@anthropic.com>
</commit_message>
<xml_diff>
--- a/Nexus_Workshop_Deck.pptx
+++ b/Nexus_Workshop_Deck.pptx
@@ -5581,7 +5581,10 @@
           <a:p>
             <a:r>
               <a:rPr lang="en-US" dirty="0"/>
-              <a:t>Everything to do with the AI lives in its own file, including the key. That separation pays off later: if you change provider, only this file changes.
+              <a:t>This is the seam from Part 1, paying off.
+One setting chooses the provider. Anthropic has its own library, so it gets its own function. OpenAI, DeepSeek, Gemini, Groq and a locally running Ollama all speak the same protocol, so a single function serves all five with a different address and model name.
+The consequence worth stating: changing provider edits one file. Nothing else in the application notices, because everything downstream only ever sees an Advice object.
+Tell them why this matters practically. Free credits run out. Providers change pricing. A key gets revoked. When that happens the question is only ever "how many files do I have to edit", and the answer here is one.
 Walk the function: if USE_MOCK is on, return a canned answer and stop. Otherwise build a prompt and call the API.
 Show them the prompt is just a sentence of plain English with numbers filled in. Students often expect prompts to be some special language. They are not.
 And note we tell the model what the automatic check already decided. We are not asking it to classify. We are asking it to explain a decision that has already been made correctly.
@@ -36143,7 +36146,7 @@
                 <a:ea typeface="Cambria" pitchFamily="34" charset="-122"/>
                 <a:cs typeface="Cambria" pitchFamily="34" charset="-120"/>
               </a:rPr>
-              <a:t>Submit a malformed request</a:t>
+              <a:t>Submit a malformed request, from /docs</a:t>
             </a:r>
             <a:endParaRPr lang="en-US" sz="3100" dirty="0"/>
           </a:p>
@@ -36158,11 +36161,11 @@
         <p:spPr>
           <a:xfrm>
             <a:off x="777240" y="1737360"/>
-            <a:ext cx="10634472" cy="777240"/>
+            <a:ext cx="10634472" cy="1005840"/>
           </a:xfrm>
           <a:prstGeom prst="roundRect">
             <a:avLst>
-              <a:gd name="adj" fmla="val 9412"/>
+              <a:gd name="adj" fmla="val 7273"/>
             </a:avLst>
           </a:prstGeom>
           <a:solidFill>
@@ -36184,8 +36187,47 @@
         </p:nvSpPr>
         <p:spPr>
           <a:xfrm>
-            <a:off x="1069848" y="1965960"/>
-            <a:ext cx="10085832" cy="411480"/>
+            <a:off x="1069848" y="1828800"/>
+            <a:ext cx="5486400" cy="274320"/>
+          </a:xfrm>
+          <a:prstGeom prst="rect">
+            <a:avLst/>
+          </a:prstGeom>
+          <a:noFill/>
+          <a:ln/>
+        </p:spPr>
+        <p:txBody>
+          <a:bodyPr wrap="square" lIns="0" tIns="0" rIns="0" bIns="0" rtlCol="0" anchor="ctr"/>
+          <a:lstStyle/>
+          <a:p>
+            <a:pPr indent="0" marL="0">
+              <a:buNone/>
+            </a:pPr>
+            <a:r>
+              <a:rPr lang="en-US" sz="1050" b="1" spc="100" kern="0" dirty="0">
+                <a:solidFill>
+                  <a:srgbClr val="8B93A3"/>
+                </a:solidFill>
+                <a:latin typeface="Courier New" pitchFamily="34" charset="0"/>
+                <a:ea typeface="Courier New" pitchFamily="34" charset="-122"/>
+                <a:cs typeface="Courier New" pitchFamily="34" charset="-120"/>
+              </a:rPr>
+              <a:t>POST /readings   in the /docs page</a:t>
+            </a:r>
+            <a:endParaRPr lang="en-US" sz="1050" dirty="0"/>
+          </a:p>
+        </p:txBody>
+      </p:sp>
+      <p:sp>
+        <p:nvSpPr>
+          <p:cNvPr id="6" name="Text 4"/>
+          <p:cNvSpPr/>
+          <p:nvPr/>
+        </p:nvSpPr>
+        <p:spPr>
+          <a:xfrm>
+            <a:off x="1069848" y="2148840"/>
+            <a:ext cx="10085832" cy="457200"/>
           </a:xfrm>
           <a:prstGeom prst="rect">
             <a:avLst/>
@@ -36220,7 +36262,7 @@
       </p:sp>
       <p:sp>
         <p:nvSpPr>
-          <p:cNvPr id="6" name="Shape 4"/>
+          <p:cNvPr id="7" name="Shape 5"/>
           <p:cNvSpPr/>
           <p:nvPr/>
         </p:nvSpPr>
@@ -36247,7 +36289,7 @@
       </p:sp>
       <p:sp>
         <p:nvSpPr>
-          <p:cNvPr id="7" name="Text 5"/>
+          <p:cNvPr id="8" name="Text 6"/>
           <p:cNvSpPr/>
           <p:nvPr/>
         </p:nvSpPr>
@@ -36286,7 +36328,7 @@
       </p:sp>
       <p:sp>
         <p:nvSpPr>
-          <p:cNvPr id="8" name="Text 6"/>
+          <p:cNvPr id="9" name="Text 7"/>
           <p:cNvSpPr/>
           <p:nvPr/>
         </p:nvSpPr>
@@ -36325,7 +36367,7 @@
       </p:sp>
       <p:sp>
         <p:nvSpPr>
-          <p:cNvPr id="9" name="Text 7"/>
+          <p:cNvPr id="10" name="Text 8"/>
           <p:cNvSpPr/>
           <p:nvPr/>
         </p:nvSpPr>
@@ -36364,7 +36406,7 @@
       </p:sp>
       <p:sp>
         <p:nvSpPr>
-          <p:cNvPr id="10" name="Text 8"/>
+          <p:cNvPr id="11" name="Text 9"/>
           <p:cNvSpPr/>
           <p:nvPr/>
         </p:nvSpPr>
@@ -36395,7 +36437,7 @@
                 <a:ea typeface="Calibri" pitchFamily="34" charset="-122"/>
                 <a:cs typeface="Calibri" pitchFamily="34" charset="-120"/>
               </a:rPr>
-              <a:t>A practice to adopt: declare the expected input structure at the application boundary, in every project.</a:t>
+              <a:t>The web page cannot send this: its input is type=number. The /docs page bypasses the page entirely.</a:t>
             </a:r>
             <a:endParaRPr lang="en-US" sz="1200" dirty="0"/>
           </a:p>
@@ -40856,7 +40898,7 @@
                 <a:ea typeface="Cambria" pitchFamily="34" charset="-122"/>
                 <a:cs typeface="Cambria" pitchFamily="34" charset="-120"/>
               </a:rPr>
-              <a:t>The AI call, in its own file</a:t>
+              <a:t>One file, any provider</a:t>
             </a:r>
             <a:endParaRPr lang="en-US" sz="3100" dirty="0"/>
           </a:p>
@@ -40871,11 +40913,11 @@
         <p:spPr>
           <a:xfrm>
             <a:off x="777240" y="1691640"/>
-            <a:ext cx="10634472" cy="4185920"/>
+            <a:ext cx="10634472" cy="4274820"/>
           </a:xfrm>
           <a:prstGeom prst="roundRect">
             <a:avLst>
-              <a:gd name="adj" fmla="val 1748"/>
+              <a:gd name="adj" fmla="val 1711"/>
             </a:avLst>
           </a:prstGeom>
           <a:solidFill>
@@ -40937,7 +40979,7 @@
         <p:spPr>
           <a:xfrm>
             <a:off x="1069848" y="2103120"/>
-            <a:ext cx="10085832" cy="3637280"/>
+            <a:ext cx="10085832" cy="3726180"/>
           </a:xfrm>
           <a:prstGeom prst="rect">
             <a:avLst/>
@@ -40951,12 +40993,12 @@
           <a:p>
             <a:pPr indent="0" marL="0">
               <a:lnSpc>
-                <a:spcPts val="1450"/>
+                <a:spcPts val="1650"/>
               </a:lnSpc>
               <a:buNone/>
             </a:pPr>
             <a:r>
-              <a:rPr lang="en-US" sz="1200" dirty="0">
+              <a:rPr lang="en-US" sz="1350" dirty="0">
                 <a:solidFill>
                   <a:srgbClr val="E6E9EF"/>
                 </a:solidFill>
@@ -40964,19 +41006,37 @@
                 <a:ea typeface="Courier New" pitchFamily="34" charset="-122"/>
                 <a:cs typeface="Courier New" pitchFamily="34" charset="-120"/>
               </a:rPr>
-              <a:t>USE_MOCK = os.getenv("USE_MOCK", "true").lower() == "true"</a:t>
-            </a:r>
-            <a:endParaRPr lang="en-US" sz="1200" dirty="0"/>
+              <a:t>PROVIDER = os.getenv("AI_PROVIDER", "mock").lower()</a:t>
+            </a:r>
+            <a:endParaRPr lang="en-US" sz="1350" dirty="0"/>
           </a:p>
           <a:p>
             <a:pPr indent="0" marL="0">
               <a:lnSpc>
-                <a:spcPts val="1450"/>
+                <a:spcPts val="1650"/>
               </a:lnSpc>
               <a:buNone/>
             </a:pPr>
-            <a:r>
-              <a:rPr lang="en-US" sz="1200" dirty="0">
+            <a:endParaRPr lang="en-US" sz="1350" dirty="0"/>
+          </a:p>
+          <a:p>
+            <a:pPr indent="0" marL="0">
+              <a:lnSpc>
+                <a:spcPts val="1650"/>
+              </a:lnSpc>
+              <a:buNone/>
+            </a:pPr>
+            <a:endParaRPr lang="en-US" sz="1350" dirty="0"/>
+          </a:p>
+          <a:p>
+            <a:pPr indent="0" marL="0">
+              <a:lnSpc>
+                <a:spcPts val="1650"/>
+              </a:lnSpc>
+              <a:buNone/>
+            </a:pPr>
+            <a:r>
+              <a:rPr lang="en-US" sz="1350" dirty="0">
                 <a:solidFill>
                   <a:srgbClr val="E6E9EF"/>
                 </a:solidFill>
@@ -40984,37 +41044,19 @@
                 <a:ea typeface="Courier New" pitchFamily="34" charset="-122"/>
                 <a:cs typeface="Courier New" pitchFamily="34" charset="-120"/>
               </a:rPr>
-              <a:t>MODEL = os.getenv("CLAUDE_MODEL", "claude-opus-5")</a:t>
-            </a:r>
-            <a:endParaRPr lang="en-US" sz="1200" dirty="0"/>
+              <a:t># Providers that speak the OpenAI protocol. Only the address and the</a:t>
+            </a:r>
+            <a:endParaRPr lang="en-US" sz="1350" dirty="0"/>
           </a:p>
           <a:p>
             <a:pPr indent="0" marL="0">
               <a:lnSpc>
-                <a:spcPts val="1450"/>
+                <a:spcPts val="1650"/>
               </a:lnSpc>
               <a:buNone/>
             </a:pPr>
-            <a:endParaRPr lang="en-US" sz="1200" dirty="0"/>
-          </a:p>
-          <a:p>
-            <a:pPr indent="0" marL="0">
-              <a:lnSpc>
-                <a:spcPts val="1450"/>
-              </a:lnSpc>
-              <a:buNone/>
-            </a:pPr>
-            <a:endParaRPr lang="en-US" sz="1200" dirty="0"/>
-          </a:p>
-          <a:p>
-            <a:pPr indent="0" marL="0">
-              <a:lnSpc>
-                <a:spcPts val="1450"/>
-              </a:lnSpc>
-              <a:buNone/>
-            </a:pPr>
-            <a:r>
-              <a:rPr lang="en-US" sz="1200" dirty="0">
+            <a:r>
+              <a:rPr lang="en-US" sz="1350" dirty="0">
                 <a:solidFill>
                   <a:srgbClr val="E6E9EF"/>
                 </a:solidFill>
@@ -41022,19 +41064,19 @@
                 <a:ea typeface="Courier New" pitchFamily="34" charset="-122"/>
                 <a:cs typeface="Courier New" pitchFamily="34" charset="-120"/>
               </a:rPr>
-              <a:t>class Advice(BaseModel):</a:t>
-            </a:r>
-            <a:endParaRPr lang="en-US" sz="1200" dirty="0"/>
+              <a:t># model name differ, which is why one function serves all of them.</a:t>
+            </a:r>
+            <a:endParaRPr lang="en-US" sz="1350" dirty="0"/>
           </a:p>
           <a:p>
             <a:pPr indent="0" marL="0">
               <a:lnSpc>
-                <a:spcPts val="1450"/>
+                <a:spcPts val="1650"/>
               </a:lnSpc>
               <a:buNone/>
             </a:pPr>
             <a:r>
-              <a:rPr lang="en-US" sz="1200" dirty="0">
+              <a:rPr lang="en-US" sz="1350" dirty="0">
                 <a:solidFill>
                   <a:srgbClr val="E6E9EF"/>
                 </a:solidFill>
@@ -41042,19 +41084,19 @@
                 <a:ea typeface="Courier New" pitchFamily="34" charset="-122"/>
                 <a:cs typeface="Courier New" pitchFamily="34" charset="-120"/>
               </a:rPr>
-              <a:t>    reason: str = Field(description="why the reading is at this level, under 15 words")</a:t>
-            </a:r>
-            <a:endParaRPr lang="en-US" sz="1200" dirty="0"/>
+              <a:t>OPENAI_COMPATIBLE = {</a:t>
+            </a:r>
+            <a:endParaRPr lang="en-US" sz="1350" dirty="0"/>
           </a:p>
           <a:p>
             <a:pPr indent="0" marL="0">
               <a:lnSpc>
-                <a:spcPts val="1450"/>
+                <a:spcPts val="1650"/>
               </a:lnSpc>
               <a:buNone/>
             </a:pPr>
             <a:r>
-              <a:rPr lang="en-US" sz="1200" dirty="0">
+              <a:rPr lang="en-US" sz="1350" dirty="0">
                 <a:solidFill>
                   <a:srgbClr val="E6E9EF"/>
                 </a:solidFill>
@@ -41062,37 +41104,19 @@
                 <a:ea typeface="Courier New" pitchFamily="34" charset="-122"/>
                 <a:cs typeface="Courier New" pitchFamily="34" charset="-120"/>
               </a:rPr>
-              <a:t>    action: str = Field(description="one concrete next step, under 10 words")</a:t>
-            </a:r>
-            <a:endParaRPr lang="en-US" sz="1200" dirty="0"/>
+              <a:t>    "openai":   ("https://api.openai.com/v1",   "OPENAI_API_KEY",   "gpt-4o-mini"),</a:t>
+            </a:r>
+            <a:endParaRPr lang="en-US" sz="1350" dirty="0"/>
           </a:p>
           <a:p>
             <a:pPr indent="0" marL="0">
               <a:lnSpc>
-                <a:spcPts val="1450"/>
+                <a:spcPts val="1650"/>
               </a:lnSpc>
               <a:buNone/>
             </a:pPr>
-            <a:endParaRPr lang="en-US" sz="1200" dirty="0"/>
-          </a:p>
-          <a:p>
-            <a:pPr indent="0" marL="0">
-              <a:lnSpc>
-                <a:spcPts val="1450"/>
-              </a:lnSpc>
-              <a:buNone/>
-            </a:pPr>
-            <a:endParaRPr lang="en-US" sz="1200" dirty="0"/>
-          </a:p>
-          <a:p>
-            <a:pPr indent="0" marL="0">
-              <a:lnSpc>
-                <a:spcPts val="1450"/>
-              </a:lnSpc>
-              <a:buNone/>
-            </a:pPr>
-            <a:r>
-              <a:rPr lang="en-US" sz="1200" dirty="0">
+            <a:r>
+              <a:rPr lang="en-US" sz="1350" dirty="0">
                 <a:solidFill>
                   <a:srgbClr val="E6E9EF"/>
                 </a:solidFill>
@@ -41100,19 +41124,19 @@
                 <a:ea typeface="Courier New" pitchFamily="34" charset="-122"/>
                 <a:cs typeface="Courier New" pitchFamily="34" charset="-120"/>
               </a:rPr>
-              <a:t>def explain(sensor, value, unit, low, high, severity) -&gt; Advice:</a:t>
-            </a:r>
-            <a:endParaRPr lang="en-US" sz="1200" dirty="0"/>
+              <a:t>    "deepseek": ("https://api.deepseek.com/v1", "DEEPSEEK_API_KEY", "deepseek-chat"),</a:t>
+            </a:r>
+            <a:endParaRPr lang="en-US" sz="1350" dirty="0"/>
           </a:p>
           <a:p>
             <a:pPr indent="0" marL="0">
               <a:lnSpc>
-                <a:spcPts val="1450"/>
+                <a:spcPts val="1650"/>
               </a:lnSpc>
               <a:buNone/>
             </a:pPr>
             <a:r>
-              <a:rPr lang="en-US" sz="1200" dirty="0">
+              <a:rPr lang="en-US" sz="1350" dirty="0">
                 <a:solidFill>
                   <a:srgbClr val="E6E9EF"/>
                 </a:solidFill>
@@ -41120,19 +41144,19 @@
                 <a:ea typeface="Courier New" pitchFamily="34" charset="-122"/>
                 <a:cs typeface="Courier New" pitchFamily="34" charset="-120"/>
               </a:rPr>
-              <a:t>    if USE_MOCK:</a:t>
-            </a:r>
-            <a:endParaRPr lang="en-US" sz="1200" dirty="0"/>
+              <a:t>    "gemini":   (".../v1beta/openai/",          "GEMINI_API_KEY",   "gemini-2.0-flash"),</a:t>
+            </a:r>
+            <a:endParaRPr lang="en-US" sz="1350" dirty="0"/>
           </a:p>
           <a:p>
             <a:pPr indent="0" marL="0">
               <a:lnSpc>
-                <a:spcPts val="1450"/>
+                <a:spcPts val="1650"/>
               </a:lnSpc>
               <a:buNone/>
             </a:pPr>
             <a:r>
-              <a:rPr lang="en-US" sz="1200" dirty="0">
+              <a:rPr lang="en-US" sz="1350" dirty="0">
                 <a:solidFill>
                   <a:srgbClr val="E6E9EF"/>
                 </a:solidFill>
@@ -41140,28 +41164,19 @@
                 <a:ea typeface="Courier New" pitchFamily="34" charset="-122"/>
                 <a:cs typeface="Courier New" pitchFamily="34" charset="-120"/>
               </a:rPr>
-              <a:t>        return Advice(reason=..., action=...)</a:t>
-            </a:r>
-            <a:endParaRPr lang="en-US" sz="1200" dirty="0"/>
+              <a:t>    "groq":     ("https://api.groq.com/openai/v1", "GROQ_API_KEY",  "llama-3.3-70b"),</a:t>
+            </a:r>
+            <a:endParaRPr lang="en-US" sz="1350" dirty="0"/>
           </a:p>
           <a:p>
             <a:pPr indent="0" marL="0">
               <a:lnSpc>
-                <a:spcPts val="1450"/>
+                <a:spcPts val="1650"/>
               </a:lnSpc>
               <a:buNone/>
             </a:pPr>
-            <a:endParaRPr lang="en-US" sz="1200" dirty="0"/>
-          </a:p>
-          <a:p>
-            <a:pPr indent="0" marL="0">
-              <a:lnSpc>
-                <a:spcPts val="1450"/>
-              </a:lnSpc>
-              <a:buNone/>
-            </a:pPr>
-            <a:r>
-              <a:rPr lang="en-US" sz="1200" dirty="0">
+            <a:r>
+              <a:rPr lang="en-US" sz="1350" dirty="0">
                 <a:solidFill>
                   <a:srgbClr val="E6E9EF"/>
                 </a:solidFill>
@@ -41169,19 +41184,19 @@
                 <a:ea typeface="Courier New" pitchFamily="34" charset="-122"/>
                 <a:cs typeface="Courier New" pitchFamily="34" charset="-120"/>
               </a:rPr>
-              <a:t>    client = anthropic.Anthropic()   # reads ANTHROPIC_API_KEY from the environment</a:t>
-            </a:r>
-            <a:endParaRPr lang="en-US" sz="1200" dirty="0"/>
+              <a:t>    "ollama":   ("http://localhost:11434/v1",   "OLLAMA_API_KEY",   "llama3.2:3b"),</a:t>
+            </a:r>
+            <a:endParaRPr lang="en-US" sz="1350" dirty="0"/>
           </a:p>
           <a:p>
             <a:pPr indent="0" marL="0">
               <a:lnSpc>
-                <a:spcPts val="1450"/>
+                <a:spcPts val="1650"/>
               </a:lnSpc>
               <a:buNone/>
             </a:pPr>
             <a:r>
-              <a:rPr lang="en-US" sz="1200" dirty="0">
+              <a:rPr lang="en-US" sz="1350" dirty="0">
                 <a:solidFill>
                   <a:srgbClr val="E6E9EF"/>
                 </a:solidFill>
@@ -41189,19 +41204,37 @@
                 <a:ea typeface="Courier New" pitchFamily="34" charset="-122"/>
                 <a:cs typeface="Courier New" pitchFamily="34" charset="-120"/>
               </a:rPr>
-              <a:t>    response = client.messages.parse(</a:t>
-            </a:r>
-            <a:endParaRPr lang="en-US" sz="1200" dirty="0"/>
+              <a:t>}</a:t>
+            </a:r>
+            <a:endParaRPr lang="en-US" sz="1350" dirty="0"/>
           </a:p>
           <a:p>
             <a:pPr indent="0" marL="0">
               <a:lnSpc>
-                <a:spcPts val="1450"/>
+                <a:spcPts val="1650"/>
               </a:lnSpc>
               <a:buNone/>
             </a:pPr>
-            <a:r>
-              <a:rPr lang="en-US" sz="1200" dirty="0">
+            <a:endParaRPr lang="en-US" sz="1350" dirty="0"/>
+          </a:p>
+          <a:p>
+            <a:pPr indent="0" marL="0">
+              <a:lnSpc>
+                <a:spcPts val="1650"/>
+              </a:lnSpc>
+              <a:buNone/>
+            </a:pPr>
+            <a:endParaRPr lang="en-US" sz="1350" dirty="0"/>
+          </a:p>
+          <a:p>
+            <a:pPr indent="0" marL="0">
+              <a:lnSpc>
+                <a:spcPts val="1650"/>
+              </a:lnSpc>
+              <a:buNone/>
+            </a:pPr>
+            <a:r>
+              <a:rPr lang="en-US" sz="1350" dirty="0">
                 <a:solidFill>
                   <a:srgbClr val="E6E9EF"/>
                 </a:solidFill>
@@ -41209,19 +41242,19 @@
                 <a:ea typeface="Courier New" pitchFamily="34" charset="-122"/>
                 <a:cs typeface="Courier New" pitchFamily="34" charset="-120"/>
               </a:rPr>
-              <a:t>        model=MODEL, max_tokens=256, system=SYSTEM,</a:t>
-            </a:r>
-            <a:endParaRPr lang="en-US" sz="1200" dirty="0"/>
+              <a:t>def explain(sensor, value, unit, low, high, severity) -&gt; Advice:</a:t>
+            </a:r>
+            <a:endParaRPr lang="en-US" sz="1350" dirty="0"/>
           </a:p>
           <a:p>
             <a:pPr indent="0" marL="0">
               <a:lnSpc>
-                <a:spcPts val="1450"/>
+                <a:spcPts val="1650"/>
               </a:lnSpc>
               <a:buNone/>
             </a:pPr>
             <a:r>
-              <a:rPr lang="en-US" sz="1200" dirty="0">
+              <a:rPr lang="en-US" sz="1350" dirty="0">
                 <a:solidFill>
                   <a:srgbClr val="E6E9EF"/>
                 </a:solidFill>
@@ -41229,19 +41262,19 @@
                 <a:ea typeface="Courier New" pitchFamily="34" charset="-122"/>
                 <a:cs typeface="Courier New" pitchFamily="34" charset="-120"/>
               </a:rPr>
-              <a:t>        messages=[{"role": "user", "content": prompt}],</a:t>
-            </a:r>
-            <a:endParaRPr lang="en-US" sz="1200" dirty="0"/>
+              <a:t>    if PROVIDER == "mock":      return _mock(...)</a:t>
+            </a:r>
+            <a:endParaRPr lang="en-US" sz="1350" dirty="0"/>
           </a:p>
           <a:p>
             <a:pPr indent="0" marL="0">
               <a:lnSpc>
-                <a:spcPts val="1450"/>
+                <a:spcPts val="1650"/>
               </a:lnSpc>
               <a:buNone/>
             </a:pPr>
             <a:r>
-              <a:rPr lang="en-US" sz="1200" dirty="0">
+              <a:rPr lang="en-US" sz="1350" dirty="0">
                 <a:solidFill>
                   <a:srgbClr val="E6E9EF"/>
                 </a:solidFill>
@@ -41249,19 +41282,19 @@
                 <a:ea typeface="Courier New" pitchFamily="34" charset="-122"/>
                 <a:cs typeface="Courier New" pitchFamily="34" charset="-120"/>
               </a:rPr>
-              <a:t>        output_format=Advice,        # this is what forces the two fields</a:t>
-            </a:r>
-            <a:endParaRPr lang="en-US" sz="1200" dirty="0"/>
+              <a:t>    if PROVIDER == "anthropic": return _anthropic(...)</a:t>
+            </a:r>
+            <a:endParaRPr lang="en-US" sz="1350" dirty="0"/>
           </a:p>
           <a:p>
             <a:pPr indent="0" marL="0">
               <a:lnSpc>
-                <a:spcPts val="1450"/>
+                <a:spcPts val="1650"/>
               </a:lnSpc>
               <a:buNone/>
             </a:pPr>
             <a:r>
-              <a:rPr lang="en-US" sz="1200" dirty="0">
+              <a:rPr lang="en-US" sz="1350" dirty="0">
                 <a:solidFill>
                   <a:srgbClr val="E6E9EF"/>
                 </a:solidFill>
@@ -41269,29 +41302,9 @@
                 <a:ea typeface="Courier New" pitchFamily="34" charset="-122"/>
                 <a:cs typeface="Courier New" pitchFamily="34" charset="-120"/>
               </a:rPr>
-              <a:t>    )</a:t>
-            </a:r>
-            <a:endParaRPr lang="en-US" sz="1200" dirty="0"/>
-          </a:p>
-          <a:p>
-            <a:pPr indent="0" marL="0">
-              <a:lnSpc>
-                <a:spcPts val="1450"/>
-              </a:lnSpc>
-              <a:buNone/>
-            </a:pPr>
-            <a:r>
-              <a:rPr lang="en-US" sz="1200" dirty="0">
-                <a:solidFill>
-                  <a:srgbClr val="E6E9EF"/>
-                </a:solidFill>
-                <a:latin typeface="Courier New" pitchFamily="34" charset="0"/>
-                <a:ea typeface="Courier New" pitchFamily="34" charset="-122"/>
-                <a:cs typeface="Courier New" pitchFamily="34" charset="-120"/>
-              </a:rPr>
-              <a:t>    return response.parsed_output</a:t>
-            </a:r>
-            <a:endParaRPr lang="en-US" sz="1200" dirty="0"/>
+              <a:t>    if PROVIDER in OPENAI_COMPATIBLE: return _openai_compatible(...)</a:t>
+            </a:r>
+            <a:endParaRPr lang="en-US" sz="1350" dirty="0"/>
           </a:p>
         </p:txBody>
       </p:sp>

</xml_diff>

<commit_message>
Show the device code as a mapping onto the browser request
The ESP32 slide showed C++ with no bridge to what students had already written. It is now a side-by-side table against the JavaScript from Stage 2: address, header, body, send, with the same four things on both sides.

Co-Authored-By: Claude Opus 5 <noreply@anthropic.com>
</commit_message>
<xml_diff>
--- a/Nexus_Workshop_Deck.pptx
+++ b/Nexus_Workshop_Deck.pptx
@@ -7216,10 +7216,10 @@
           <a:p>
             <a:r>
               <a:rPr lang="en-US" dirty="0"/>
-              <a:t>This part is reference material rather than something to build together. Cover 4.1 and 4.2 properly, and point at the rest in the guide.
-4.1 is the one most of this room needs -- connecting a real device -- and it deserves full attention because it requires no server changes at all.
-4.2 is the positioning slide: every other workshop in this series produces something that lives on a laptop or a device. Yours is the only one that ends with a public address. Say that explicitly; it reframes what they have just built.
-The remaining five items are pointers with code in the guide. Do not try to teach them all. If you have time for one, make it "make it feel fast" -- the pattern applies far beyond AI.</a:t>
+              <a:t>This part is reference material rather than something to build together. Cover 5.1 and 5.2 properly and point at the rest in the guide.
+5.1 is the section most of this room needs, because many of these teams have hardware. It deserves full attention, and the message is that it requires no change to the server at all.
+5.2 is the positioning slide: every other workshop in this series produces something that runs on a laptop or a device. This is the only one that ends with a public address. Saying that explicitly reframes what they have just built.
+The remaining five items are pointers with code in the guide. If you have time for only one, take the second: answering immediately and completing the AI response afterwards. That pattern applies well beyond AI.</a:t>
             </a:r>
             <a:endParaRPr lang="en-US" dirty="0"/>
           </a:p>
@@ -7307,12 +7307,13 @@
           <a:p>
             <a:r>
               <a:rPr lang="en-US" dirty="0"/>
-              <a:t>This is the section most of this room needs, so give it proper time.
-The important message is the first line: no server changes. They built an endpoint that accepts JSON, and JSON is JSON regardless of what sent it.
-Three practical notes worth saying:
-setInsecure() skips checking the HTTPS certificate. Fine for a prototype on your own service; not what you would ship.
-Watch the free tier's sleep. A device posting once an hour hits a sleeping server every single time. Posting every few minutes keeps it awake.
-For a real deployment you would store safe ranges per sensor in the database, so the device only sends a reading rather than the range every time.</a:t>
+              <a:t>This slide answers a question the room will have: why does the hardware code look so different?
+It does not. Walk the table row by row and show that each line has a direct equivalent in the JavaScript they wrote in Stage 2. Address, header, body, send. The same four things.
+Two differences worth naming:
+The browser negotiates HTTPS for you. On a microcontroller you do it yourself, and setInsecure() skips certificate checking, which is acceptable for a prototype against your own service and is not what you would ship.
+The ESP32 has no JSON library, so the body is assembled as a string and every quote has to be escaped. That is why it looks awkward. It is the same JSON.
+The message to land: your endpoint accepts JSON and does not know or care what sent it. A browser, a phone, a Python script and a microcontroller are indistinguishable to it. That is why no server change is required.
+Practical note: if the device posts once an hour, a sleeping free service will be asleep every time. Posting every few minutes keeps it awake.</a:t>
             </a:r>
             <a:endParaRPr lang="en-US" dirty="0"/>
           </a:p>
@@ -51589,7 +51590,7 @@
                 <a:ea typeface="Calibri" pitchFamily="34" charset="-122"/>
                 <a:cs typeface="Calibri" pitchFamily="34" charset="-120"/>
               </a:rPr>
-              <a:t>Including how the other nine workshops plug into what you built.</a:t>
+              <a:t>Including how the other nine workshops connect to what you have built.</a:t>
             </a:r>
             <a:endParaRPr lang="en-US" sz="1600" dirty="0"/>
           </a:p>
@@ -51699,73 +51700,1301 @@
                 <a:ea typeface="Cambria" pitchFamily="34" charset="-122"/>
                 <a:cs typeface="Cambria" pitchFamily="34" charset="-120"/>
               </a:rPr>
-              <a:t>Connect a real device</a:t>
+              <a:t>A device sends the same request your page already sends</a:t>
             </a:r>
             <a:endParaRPr lang="en-US" sz="3100" dirty="0"/>
           </a:p>
         </p:txBody>
       </p:sp>
-      <p:sp>
-        <p:nvSpPr>
-          <p:cNvPr id="4" name="Text 2"/>
-          <p:cNvSpPr/>
-          <p:nvPr/>
-        </p:nvSpPr>
-        <p:spPr>
-          <a:xfrm>
-            <a:off x="777240" y="1417320"/>
-            <a:ext cx="10634472" cy="822960"/>
-          </a:xfrm>
-          <a:prstGeom prst="rect">
-            <a:avLst/>
-          </a:prstGeom>
-          <a:noFill/>
-          <a:ln/>
-        </p:spPr>
-        <p:txBody>
-          <a:bodyPr wrap="square" lIns="0" tIns="0" rIns="0" bIns="0" rtlCol="0" anchor="ctr"/>
-          <a:lstStyle/>
-          <a:p>
-            <a:pPr indent="0" marL="0">
-              <a:buNone/>
-            </a:pPr>
-            <a:r>
-              <a:rPr lang="en-US" sz="2000" b="1" dirty="0">
-                <a:solidFill>
-                  <a:srgbClr val="00776A"/>
-                </a:solidFill>
-                <a:latin typeface="Cambria" pitchFamily="34" charset="0"/>
-                <a:ea typeface="Cambria" pitchFamily="34" charset="-122"/>
-                <a:cs typeface="Cambria" pitchFamily="34" charset="-120"/>
-              </a:rPr>
-              <a:t>This requires no modification to the server.</a:t>
-            </a:r>
-            <a:endParaRPr lang="en-US" sz="2000" dirty="0"/>
-          </a:p>
-        </p:txBody>
-      </p:sp>
-      <p:sp>
-        <p:nvSpPr>
-          <p:cNvPr id="5" name="Shape 3"/>
-          <p:cNvSpPr/>
-          <p:nvPr/>
-        </p:nvSpPr>
-        <p:spPr>
-          <a:xfrm>
-            <a:off x="777240" y="2057400"/>
-            <a:ext cx="10634472" cy="3087370"/>
+      <p:graphicFrame>
+        <p:nvGraphicFramePr>
+          <p:cNvPr id="75" name="Table 0"/>
+          <p:cNvGraphicFramePr>
+            <a:graphicFrameLocks noGrp="1"/>
+          </p:cNvGraphicFramePr>
+          <p:nvPr>
+            <p:extLst>
+              <p:ext uri="{D42A27DB-BD31-4B8C-83A1-F6EECF244321}">
+                <p14:modId xmlns:p14="http://schemas.microsoft.com/office/powerpoint/2010/main" val="1579011935"/>
+              </p:ext>
+            </p:extLst>
+          </p:nvPr>
+        </p:nvGraphicFramePr>
+        <p:xfrm>
+          <a:off x="777240" y="1691640"/>
+          <a:ext cx="10634472" cy="914400"/>
+        </p:xfrm>
+        <a:graphic>
+          <a:graphicData uri="http://schemas.openxmlformats.org/drawingml/2006/table">
+            <a:tbl>
+              <a:tblPr/>
+              <a:tblGrid>
+                <a:gridCol w="4114800"/>
+                <a:gridCol w="3931920"/>
+                <a:gridCol w="2587752"/>
+              </a:tblGrid>
+              <a:tr h="713232">
+                <a:tc>
+                  <a:txBody>
+                    <a:bodyPr/>
+                    <a:lstStyle/>
+                    <a:p>
+                      <a:pPr indent="0" marL="0">
+                        <a:buNone/>
+                      </a:pPr>
+                      <a:r>
+                        <a:rPr lang="en-US" sz="1100" b="1" dirty="0">
+                          <a:solidFill>
+                            <a:srgbClr val="00776A"/>
+                          </a:solidFill>
+                          <a:latin typeface="Courier New" pitchFamily="34" charset="0"/>
+                          <a:ea typeface="Courier New" pitchFamily="34" charset="-122"/>
+                          <a:cs typeface="Courier New" pitchFamily="34" charset="-120"/>
+                        </a:rPr>
+                        <a:t>On an ESP32, in C++</a:t>
+                      </a:r>
+                      <a:endParaRPr lang="en-US" sz="1100" dirty="0">
+                        <a:latin typeface="Courier New" charset="0"/>
+                        <a:ea typeface="Courier New" charset="0"/>
+                        <a:cs typeface="Courier New" charset="0"/>
+                      </a:endParaRPr>
+                    </a:p>
+                  </a:txBody>
+                  <a:tcPr marL="91440" marR="91440" marT="45720" marB="45720" anchor="ctr">
+                    <a:lnL w="12700" cap="flat" cmpd="sng" algn="ctr">
+                      <a:solidFill>
+                        <a:srgbClr val="E1E4E9"/>
+                      </a:solidFill>
+                      <a:prstDash val="solid"/>
+                      <a:round/>
+                      <a:headEnd type="none" w="med" len="med"/>
+                      <a:tailEnd type="none" w="med" len="med"/>
+                    </a:lnL>
+                    <a:lnR w="12700" cap="flat" cmpd="sng" algn="ctr">
+                      <a:solidFill>
+                        <a:srgbClr val="E1E4E9"/>
+                      </a:solidFill>
+                      <a:prstDash val="solid"/>
+                      <a:round/>
+                      <a:headEnd type="none" w="med" len="med"/>
+                      <a:tailEnd type="none" w="med" len="med"/>
+                    </a:lnR>
+                    <a:lnT w="12700" cap="flat" cmpd="sng" algn="ctr">
+                      <a:solidFill>
+                        <a:srgbClr val="E1E4E9"/>
+                      </a:solidFill>
+                      <a:prstDash val="solid"/>
+                      <a:round/>
+                      <a:headEnd type="none" w="med" len="med"/>
+                      <a:tailEnd type="none" w="med" len="med"/>
+                    </a:lnT>
+                    <a:lnB w="12700" cap="flat" cmpd="sng" algn="ctr">
+                      <a:solidFill>
+                        <a:srgbClr val="E1E4E9"/>
+                      </a:solidFill>
+                      <a:prstDash val="solid"/>
+                      <a:round/>
+                      <a:headEnd type="none" w="med" len="med"/>
+                      <a:tailEnd type="none" w="med" len="med"/>
+                    </a:lnB>
+                    <a:solidFill>
+                      <a:srgbClr val="FFFFFF"/>
+                    </a:solidFill>
+                  </a:tcPr>
+                </a:tc>
+                <a:tc>
+                  <a:txBody>
+                    <a:bodyPr/>
+                    <a:lstStyle/>
+                    <a:p>
+                      <a:pPr indent="0" marL="0">
+                        <a:buNone/>
+                      </a:pPr>
+                      <a:r>
+                        <a:rPr lang="en-US" sz="1100" b="1" dirty="0">
+                          <a:solidFill>
+                            <a:srgbClr val="5158BE"/>
+                          </a:solidFill>
+                          <a:latin typeface="Courier New" pitchFamily="34" charset="0"/>
+                          <a:ea typeface="Courier New" pitchFamily="34" charset="-122"/>
+                          <a:cs typeface="Courier New" pitchFamily="34" charset="-120"/>
+                        </a:rPr>
+                        <a:t>In your web page</a:t>
+                      </a:r>
+                      <a:endParaRPr lang="en-US" sz="1100" dirty="0">
+                        <a:latin typeface="Courier New" charset="0"/>
+                        <a:ea typeface="Courier New" charset="0"/>
+                        <a:cs typeface="Courier New" charset="0"/>
+                      </a:endParaRPr>
+                    </a:p>
+                  </a:txBody>
+                  <a:tcPr marL="91440" marR="91440" marT="45720" marB="45720" anchor="ctr">
+                    <a:lnL w="12700" cap="flat" cmpd="sng" algn="ctr">
+                      <a:solidFill>
+                        <a:srgbClr val="E1E4E9"/>
+                      </a:solidFill>
+                      <a:prstDash val="solid"/>
+                      <a:round/>
+                      <a:headEnd type="none" w="med" len="med"/>
+                      <a:tailEnd type="none" w="med" len="med"/>
+                    </a:lnL>
+                    <a:lnR w="12700" cap="flat" cmpd="sng" algn="ctr">
+                      <a:solidFill>
+                        <a:srgbClr val="E1E4E9"/>
+                      </a:solidFill>
+                      <a:prstDash val="solid"/>
+                      <a:round/>
+                      <a:headEnd type="none" w="med" len="med"/>
+                      <a:tailEnd type="none" w="med" len="med"/>
+                    </a:lnR>
+                    <a:lnT w="12700" cap="flat" cmpd="sng" algn="ctr">
+                      <a:solidFill>
+                        <a:srgbClr val="E1E4E9"/>
+                      </a:solidFill>
+                      <a:prstDash val="solid"/>
+                      <a:round/>
+                      <a:headEnd type="none" w="med" len="med"/>
+                      <a:tailEnd type="none" w="med" len="med"/>
+                    </a:lnT>
+                    <a:lnB w="12700" cap="flat" cmpd="sng" algn="ctr">
+                      <a:solidFill>
+                        <a:srgbClr val="E1E4E9"/>
+                      </a:solidFill>
+                      <a:prstDash val="solid"/>
+                      <a:round/>
+                      <a:headEnd type="none" w="med" len="med"/>
+                      <a:tailEnd type="none" w="med" len="med"/>
+                    </a:lnB>
+                    <a:solidFill>
+                      <a:srgbClr val="FFFFFF"/>
+                    </a:solidFill>
+                  </a:tcPr>
+                </a:tc>
+                <a:tc>
+                  <a:txBody>
+                    <a:bodyPr/>
+                    <a:lstStyle/>
+                    <a:p>
+                      <a:pPr indent="0" marL="0">
+                        <a:buNone/>
+                      </a:pPr>
+                      <a:r>
+                        <a:rPr lang="en-US" sz="1100" b="1" dirty="0">
+                          <a:solidFill>
+                            <a:srgbClr val="15181F"/>
+                          </a:solidFill>
+                          <a:latin typeface="Courier New" pitchFamily="34" charset="0"/>
+                          <a:ea typeface="Courier New" pitchFamily="34" charset="-122"/>
+                          <a:cs typeface="Courier New" pitchFamily="34" charset="-120"/>
+                        </a:rPr>
+                        <a:t>What it does</a:t>
+                      </a:r>
+                      <a:endParaRPr lang="en-US" sz="1100" dirty="0">
+                        <a:latin typeface="Courier New" charset="0"/>
+                        <a:ea typeface="Courier New" charset="0"/>
+                        <a:cs typeface="Courier New" charset="0"/>
+                      </a:endParaRPr>
+                    </a:p>
+                  </a:txBody>
+                  <a:tcPr marL="91440" marR="91440" marT="45720" marB="45720" anchor="ctr">
+                    <a:lnL w="12700" cap="flat" cmpd="sng" algn="ctr">
+                      <a:solidFill>
+                        <a:srgbClr val="E1E4E9"/>
+                      </a:solidFill>
+                      <a:prstDash val="solid"/>
+                      <a:round/>
+                      <a:headEnd type="none" w="med" len="med"/>
+                      <a:tailEnd type="none" w="med" len="med"/>
+                    </a:lnL>
+                    <a:lnR w="12700" cap="flat" cmpd="sng" algn="ctr">
+                      <a:solidFill>
+                        <a:srgbClr val="E1E4E9"/>
+                      </a:solidFill>
+                      <a:prstDash val="solid"/>
+                      <a:round/>
+                      <a:headEnd type="none" w="med" len="med"/>
+                      <a:tailEnd type="none" w="med" len="med"/>
+                    </a:lnR>
+                    <a:lnT w="12700" cap="flat" cmpd="sng" algn="ctr">
+                      <a:solidFill>
+                        <a:srgbClr val="E1E4E9"/>
+                      </a:solidFill>
+                      <a:prstDash val="solid"/>
+                      <a:round/>
+                      <a:headEnd type="none" w="med" len="med"/>
+                      <a:tailEnd type="none" w="med" len="med"/>
+                    </a:lnT>
+                    <a:lnB w="12700" cap="flat" cmpd="sng" algn="ctr">
+                      <a:solidFill>
+                        <a:srgbClr val="E1E4E9"/>
+                      </a:solidFill>
+                      <a:prstDash val="solid"/>
+                      <a:round/>
+                      <a:headEnd type="none" w="med" len="med"/>
+                      <a:tailEnd type="none" w="med" len="med"/>
+                    </a:lnB>
+                    <a:solidFill>
+                      <a:srgbClr val="FFFFFF"/>
+                    </a:solidFill>
+                  </a:tcPr>
+                </a:tc>
+              </a:tr>
+              <a:tr h="713232">
+                <a:tc>
+                  <a:txBody>
+                    <a:bodyPr/>
+                    <a:lstStyle/>
+                    <a:p>
+                      <a:pPr indent="0" marL="0">
+                        <a:buNone/>
+                      </a:pPr>
+                      <a:r>
+                        <a:rPr lang="en-US" sz="1100" dirty="0">
+                          <a:solidFill>
+                            <a:srgbClr val="15181F"/>
+                          </a:solidFill>
+                          <a:latin typeface="Courier New" pitchFamily="34" charset="0"/>
+                          <a:ea typeface="Courier New" pitchFamily="34" charset="-122"/>
+                          <a:cs typeface="Courier New" pitchFamily="34" charset="-120"/>
+                        </a:rPr>
+                        <a:t>WiFiClientSecure client;</a:t>
+                      </a:r>
+                      <a:endParaRPr lang="en-US" sz="1100" dirty="0">
+                        <a:latin typeface="Courier New" charset="0"/>
+                        <a:ea typeface="Courier New" charset="0"/>
+                        <a:cs typeface="Courier New" charset="0"/>
+                      </a:endParaRPr>
+                    </a:p>
+                  </a:txBody>
+                  <a:tcPr marL="91440" marR="91440" marT="45720" marB="45720" anchor="ctr">
+                    <a:lnL w="12700" cap="flat" cmpd="sng" algn="ctr">
+                      <a:solidFill>
+                        <a:srgbClr val="E1E4E9"/>
+                      </a:solidFill>
+                      <a:prstDash val="solid"/>
+                      <a:round/>
+                      <a:headEnd type="none" w="med" len="med"/>
+                      <a:tailEnd type="none" w="med" len="med"/>
+                    </a:lnL>
+                    <a:lnR w="12700" cap="flat" cmpd="sng" algn="ctr">
+                      <a:solidFill>
+                        <a:srgbClr val="E1E4E9"/>
+                      </a:solidFill>
+                      <a:prstDash val="solid"/>
+                      <a:round/>
+                      <a:headEnd type="none" w="med" len="med"/>
+                      <a:tailEnd type="none" w="med" len="med"/>
+                    </a:lnR>
+                    <a:lnT w="12700" cap="flat" cmpd="sng" algn="ctr">
+                      <a:solidFill>
+                        <a:srgbClr val="E1E4E9"/>
+                      </a:solidFill>
+                      <a:prstDash val="solid"/>
+                      <a:round/>
+                      <a:headEnd type="none" w="med" len="med"/>
+                      <a:tailEnd type="none" w="med" len="med"/>
+                    </a:lnT>
+                    <a:lnB w="12700" cap="flat" cmpd="sng" algn="ctr">
+                      <a:solidFill>
+                        <a:srgbClr val="E1E4E9"/>
+                      </a:solidFill>
+                      <a:prstDash val="solid"/>
+                      <a:round/>
+                      <a:headEnd type="none" w="med" len="med"/>
+                      <a:tailEnd type="none" w="med" len="med"/>
+                    </a:lnB>
+                    <a:solidFill>
+                      <a:srgbClr val="FFFFFF"/>
+                    </a:solidFill>
+                  </a:tcPr>
+                </a:tc>
+                <a:tc>
+                  <a:txBody>
+                    <a:bodyPr/>
+                    <a:lstStyle/>
+                    <a:p>
+                      <a:pPr indent="0" marL="0">
+                        <a:buNone/>
+                      </a:pPr>
+                      <a:r>
+                        <a:rPr lang="en-US" sz="1100" dirty="0">
+                          <a:solidFill>
+                            <a:srgbClr val="15181F"/>
+                          </a:solidFill>
+                          <a:latin typeface="Courier New" pitchFamily="34" charset="0"/>
+                          <a:ea typeface="Courier New" pitchFamily="34" charset="-122"/>
+                          <a:cs typeface="Courier New" pitchFamily="34" charset="-120"/>
+                        </a:rPr>
+                        <a:t>the browser does this</a:t>
+                      </a:r>
+                      <a:endParaRPr lang="en-US" sz="1100" dirty="0">
+                        <a:latin typeface="Courier New" charset="0"/>
+                        <a:ea typeface="Courier New" charset="0"/>
+                        <a:cs typeface="Courier New" charset="0"/>
+                      </a:endParaRPr>
+                    </a:p>
+                  </a:txBody>
+                  <a:tcPr marL="91440" marR="91440" marT="45720" marB="45720" anchor="ctr">
+                    <a:lnL w="12700" cap="flat" cmpd="sng" algn="ctr">
+                      <a:solidFill>
+                        <a:srgbClr val="E1E4E9"/>
+                      </a:solidFill>
+                      <a:prstDash val="solid"/>
+                      <a:round/>
+                      <a:headEnd type="none" w="med" len="med"/>
+                      <a:tailEnd type="none" w="med" len="med"/>
+                    </a:lnL>
+                    <a:lnR w="12700" cap="flat" cmpd="sng" algn="ctr">
+                      <a:solidFill>
+                        <a:srgbClr val="E1E4E9"/>
+                      </a:solidFill>
+                      <a:prstDash val="solid"/>
+                      <a:round/>
+                      <a:headEnd type="none" w="med" len="med"/>
+                      <a:tailEnd type="none" w="med" len="med"/>
+                    </a:lnR>
+                    <a:lnT w="12700" cap="flat" cmpd="sng" algn="ctr">
+                      <a:solidFill>
+                        <a:srgbClr val="E1E4E9"/>
+                      </a:solidFill>
+                      <a:prstDash val="solid"/>
+                      <a:round/>
+                      <a:headEnd type="none" w="med" len="med"/>
+                      <a:tailEnd type="none" w="med" len="med"/>
+                    </a:lnT>
+                    <a:lnB w="12700" cap="flat" cmpd="sng" algn="ctr">
+                      <a:solidFill>
+                        <a:srgbClr val="E1E4E9"/>
+                      </a:solidFill>
+                      <a:prstDash val="solid"/>
+                      <a:round/>
+                      <a:headEnd type="none" w="med" len="med"/>
+                      <a:tailEnd type="none" w="med" len="med"/>
+                    </a:lnB>
+                    <a:solidFill>
+                      <a:srgbClr val="FFFFFF"/>
+                    </a:solidFill>
+                  </a:tcPr>
+                </a:tc>
+                <a:tc>
+                  <a:txBody>
+                    <a:bodyPr/>
+                    <a:lstStyle/>
+                    <a:p>
+                      <a:pPr indent="0" marL="0">
+                        <a:buNone/>
+                      </a:pPr>
+                      <a:r>
+                        <a:rPr lang="en-US" sz="1100" dirty="0">
+                          <a:solidFill>
+                            <a:srgbClr val="15181F"/>
+                          </a:solidFill>
+                          <a:latin typeface="Courier New" pitchFamily="34" charset="0"/>
+                          <a:ea typeface="Courier New" pitchFamily="34" charset="-122"/>
+                          <a:cs typeface="Courier New" pitchFamily="34" charset="-120"/>
+                        </a:rPr>
+                        <a:t>establish HTTPS</a:t>
+                      </a:r>
+                      <a:endParaRPr lang="en-US" sz="1100" dirty="0">
+                        <a:latin typeface="Courier New" charset="0"/>
+                        <a:ea typeface="Courier New" charset="0"/>
+                        <a:cs typeface="Courier New" charset="0"/>
+                      </a:endParaRPr>
+                    </a:p>
+                  </a:txBody>
+                  <a:tcPr marL="91440" marR="91440" marT="45720" marB="45720" anchor="ctr">
+                    <a:lnL w="12700" cap="flat" cmpd="sng" algn="ctr">
+                      <a:solidFill>
+                        <a:srgbClr val="E1E4E9"/>
+                      </a:solidFill>
+                      <a:prstDash val="solid"/>
+                      <a:round/>
+                      <a:headEnd type="none" w="med" len="med"/>
+                      <a:tailEnd type="none" w="med" len="med"/>
+                    </a:lnL>
+                    <a:lnR w="12700" cap="flat" cmpd="sng" algn="ctr">
+                      <a:solidFill>
+                        <a:srgbClr val="E1E4E9"/>
+                      </a:solidFill>
+                      <a:prstDash val="solid"/>
+                      <a:round/>
+                      <a:headEnd type="none" w="med" len="med"/>
+                      <a:tailEnd type="none" w="med" len="med"/>
+                    </a:lnR>
+                    <a:lnT w="12700" cap="flat" cmpd="sng" algn="ctr">
+                      <a:solidFill>
+                        <a:srgbClr val="E1E4E9"/>
+                      </a:solidFill>
+                      <a:prstDash val="solid"/>
+                      <a:round/>
+                      <a:headEnd type="none" w="med" len="med"/>
+                      <a:tailEnd type="none" w="med" len="med"/>
+                    </a:lnT>
+                    <a:lnB w="12700" cap="flat" cmpd="sng" algn="ctr">
+                      <a:solidFill>
+                        <a:srgbClr val="E1E4E9"/>
+                      </a:solidFill>
+                      <a:prstDash val="solid"/>
+                      <a:round/>
+                      <a:headEnd type="none" w="med" len="med"/>
+                      <a:tailEnd type="none" w="med" len="med"/>
+                    </a:lnB>
+                    <a:solidFill>
+                      <a:srgbClr val="FFFFFF"/>
+                    </a:solidFill>
+                  </a:tcPr>
+                </a:tc>
+              </a:tr>
+              <a:tr h="713232">
+                <a:tc>
+                  <a:txBody>
+                    <a:bodyPr/>
+                    <a:lstStyle/>
+                    <a:p>
+                      <a:pPr indent="0" marL="0">
+                        <a:buNone/>
+                      </a:pPr>
+                      <a:r>
+                        <a:rPr lang="en-US" sz="1100" dirty="0">
+                          <a:solidFill>
+                            <a:srgbClr val="15181F"/>
+                          </a:solidFill>
+                          <a:latin typeface="Courier New" pitchFamily="34" charset="0"/>
+                          <a:ea typeface="Courier New" pitchFamily="34" charset="-122"/>
+                          <a:cs typeface="Courier New" pitchFamily="34" charset="-120"/>
+                        </a:rPr>
+                        <a:t>http.begin(client, ENDPOINT)</a:t>
+                      </a:r>
+                      <a:endParaRPr lang="en-US" sz="1100" dirty="0">
+                        <a:latin typeface="Courier New" charset="0"/>
+                        <a:ea typeface="Courier New" charset="0"/>
+                        <a:cs typeface="Courier New" charset="0"/>
+                      </a:endParaRPr>
+                    </a:p>
+                  </a:txBody>
+                  <a:tcPr marL="91440" marR="91440" marT="45720" marB="45720" anchor="ctr">
+                    <a:lnL w="12700" cap="flat" cmpd="sng" algn="ctr">
+                      <a:solidFill>
+                        <a:srgbClr val="E1E4E9"/>
+                      </a:solidFill>
+                      <a:prstDash val="solid"/>
+                      <a:round/>
+                      <a:headEnd type="none" w="med" len="med"/>
+                      <a:tailEnd type="none" w="med" len="med"/>
+                    </a:lnL>
+                    <a:lnR w="12700" cap="flat" cmpd="sng" algn="ctr">
+                      <a:solidFill>
+                        <a:srgbClr val="E1E4E9"/>
+                      </a:solidFill>
+                      <a:prstDash val="solid"/>
+                      <a:round/>
+                      <a:headEnd type="none" w="med" len="med"/>
+                      <a:tailEnd type="none" w="med" len="med"/>
+                    </a:lnR>
+                    <a:lnT w="12700" cap="flat" cmpd="sng" algn="ctr">
+                      <a:solidFill>
+                        <a:srgbClr val="E1E4E9"/>
+                      </a:solidFill>
+                      <a:prstDash val="solid"/>
+                      <a:round/>
+                      <a:headEnd type="none" w="med" len="med"/>
+                      <a:tailEnd type="none" w="med" len="med"/>
+                    </a:lnT>
+                    <a:lnB w="12700" cap="flat" cmpd="sng" algn="ctr">
+                      <a:solidFill>
+                        <a:srgbClr val="E1E4E9"/>
+                      </a:solidFill>
+                      <a:prstDash val="solid"/>
+                      <a:round/>
+                      <a:headEnd type="none" w="med" len="med"/>
+                      <a:tailEnd type="none" w="med" len="med"/>
+                    </a:lnB>
+                    <a:solidFill>
+                      <a:srgbClr val="FFFFFF"/>
+                    </a:solidFill>
+                  </a:tcPr>
+                </a:tc>
+                <a:tc>
+                  <a:txBody>
+                    <a:bodyPr/>
+                    <a:lstStyle/>
+                    <a:p>
+                      <a:pPr indent="0" marL="0">
+                        <a:buNone/>
+                      </a:pPr>
+                      <a:r>
+                        <a:rPr lang="en-US" sz="1100" dirty="0">
+                          <a:solidFill>
+                            <a:srgbClr val="15181F"/>
+                          </a:solidFill>
+                          <a:latin typeface="Courier New" pitchFamily="34" charset="0"/>
+                          <a:ea typeface="Courier New" pitchFamily="34" charset="-122"/>
+                          <a:cs typeface="Courier New" pitchFamily="34" charset="-120"/>
+                        </a:rPr>
+                        <a:t>fetch(url, ...)</a:t>
+                      </a:r>
+                      <a:endParaRPr lang="en-US" sz="1100" dirty="0">
+                        <a:latin typeface="Courier New" charset="0"/>
+                        <a:ea typeface="Courier New" charset="0"/>
+                        <a:cs typeface="Courier New" charset="0"/>
+                      </a:endParaRPr>
+                    </a:p>
+                  </a:txBody>
+                  <a:tcPr marL="91440" marR="91440" marT="45720" marB="45720" anchor="ctr">
+                    <a:lnL w="12700" cap="flat" cmpd="sng" algn="ctr">
+                      <a:solidFill>
+                        <a:srgbClr val="E1E4E9"/>
+                      </a:solidFill>
+                      <a:prstDash val="solid"/>
+                      <a:round/>
+                      <a:headEnd type="none" w="med" len="med"/>
+                      <a:tailEnd type="none" w="med" len="med"/>
+                    </a:lnL>
+                    <a:lnR w="12700" cap="flat" cmpd="sng" algn="ctr">
+                      <a:solidFill>
+                        <a:srgbClr val="E1E4E9"/>
+                      </a:solidFill>
+                      <a:prstDash val="solid"/>
+                      <a:round/>
+                      <a:headEnd type="none" w="med" len="med"/>
+                      <a:tailEnd type="none" w="med" len="med"/>
+                    </a:lnR>
+                    <a:lnT w="12700" cap="flat" cmpd="sng" algn="ctr">
+                      <a:solidFill>
+                        <a:srgbClr val="E1E4E9"/>
+                      </a:solidFill>
+                      <a:prstDash val="solid"/>
+                      <a:round/>
+                      <a:headEnd type="none" w="med" len="med"/>
+                      <a:tailEnd type="none" w="med" len="med"/>
+                    </a:lnT>
+                    <a:lnB w="12700" cap="flat" cmpd="sng" algn="ctr">
+                      <a:solidFill>
+                        <a:srgbClr val="E1E4E9"/>
+                      </a:solidFill>
+                      <a:prstDash val="solid"/>
+                      <a:round/>
+                      <a:headEnd type="none" w="med" len="med"/>
+                      <a:tailEnd type="none" w="med" len="med"/>
+                    </a:lnB>
+                    <a:solidFill>
+                      <a:srgbClr val="FFFFFF"/>
+                    </a:solidFill>
+                  </a:tcPr>
+                </a:tc>
+                <a:tc>
+                  <a:txBody>
+                    <a:bodyPr/>
+                    <a:lstStyle/>
+                    <a:p>
+                      <a:pPr indent="0" marL="0">
+                        <a:buNone/>
+                      </a:pPr>
+                      <a:r>
+                        <a:rPr lang="en-US" sz="1100" dirty="0">
+                          <a:solidFill>
+                            <a:srgbClr val="15181F"/>
+                          </a:solidFill>
+                          <a:latin typeface="Courier New" pitchFamily="34" charset="0"/>
+                          <a:ea typeface="Courier New" pitchFamily="34" charset="-122"/>
+                          <a:cs typeface="Courier New" pitchFamily="34" charset="-120"/>
+                        </a:rPr>
+                        <a:t>the address</a:t>
+                      </a:r>
+                      <a:endParaRPr lang="en-US" sz="1100" dirty="0">
+                        <a:latin typeface="Courier New" charset="0"/>
+                        <a:ea typeface="Courier New" charset="0"/>
+                        <a:cs typeface="Courier New" charset="0"/>
+                      </a:endParaRPr>
+                    </a:p>
+                  </a:txBody>
+                  <a:tcPr marL="91440" marR="91440" marT="45720" marB="45720" anchor="ctr">
+                    <a:lnL w="12700" cap="flat" cmpd="sng" algn="ctr">
+                      <a:solidFill>
+                        <a:srgbClr val="E1E4E9"/>
+                      </a:solidFill>
+                      <a:prstDash val="solid"/>
+                      <a:round/>
+                      <a:headEnd type="none" w="med" len="med"/>
+                      <a:tailEnd type="none" w="med" len="med"/>
+                    </a:lnL>
+                    <a:lnR w="12700" cap="flat" cmpd="sng" algn="ctr">
+                      <a:solidFill>
+                        <a:srgbClr val="E1E4E9"/>
+                      </a:solidFill>
+                      <a:prstDash val="solid"/>
+                      <a:round/>
+                      <a:headEnd type="none" w="med" len="med"/>
+                      <a:tailEnd type="none" w="med" len="med"/>
+                    </a:lnR>
+                    <a:lnT w="12700" cap="flat" cmpd="sng" algn="ctr">
+                      <a:solidFill>
+                        <a:srgbClr val="E1E4E9"/>
+                      </a:solidFill>
+                      <a:prstDash val="solid"/>
+                      <a:round/>
+                      <a:headEnd type="none" w="med" len="med"/>
+                      <a:tailEnd type="none" w="med" len="med"/>
+                    </a:lnT>
+                    <a:lnB w="12700" cap="flat" cmpd="sng" algn="ctr">
+                      <a:solidFill>
+                        <a:srgbClr val="E1E4E9"/>
+                      </a:solidFill>
+                      <a:prstDash val="solid"/>
+                      <a:round/>
+                      <a:headEnd type="none" w="med" len="med"/>
+                      <a:tailEnd type="none" w="med" len="med"/>
+                    </a:lnB>
+                    <a:solidFill>
+                      <a:srgbClr val="FFFFFF"/>
+                    </a:solidFill>
+                  </a:tcPr>
+                </a:tc>
+              </a:tr>
+              <a:tr h="713232">
+                <a:tc>
+                  <a:txBody>
+                    <a:bodyPr/>
+                    <a:lstStyle/>
+                    <a:p>
+                      <a:pPr indent="0" marL="0">
+                        <a:buNone/>
+                      </a:pPr>
+                      <a:r>
+                        <a:rPr lang="en-US" sz="1100" dirty="0">
+                          <a:solidFill>
+                            <a:srgbClr val="15181F"/>
+                          </a:solidFill>
+                          <a:latin typeface="Courier New" pitchFamily="34" charset="0"/>
+                          <a:ea typeface="Courier New" pitchFamily="34" charset="-122"/>
+                          <a:cs typeface="Courier New" pitchFamily="34" charset="-120"/>
+                        </a:rPr>
+                        <a:t>http.addHeader(Content-Type)</a:t>
+                      </a:r>
+                      <a:endParaRPr lang="en-US" sz="1100" dirty="0">
+                        <a:latin typeface="Courier New" charset="0"/>
+                        <a:ea typeface="Courier New" charset="0"/>
+                        <a:cs typeface="Courier New" charset="0"/>
+                      </a:endParaRPr>
+                    </a:p>
+                  </a:txBody>
+                  <a:tcPr marL="91440" marR="91440" marT="45720" marB="45720" anchor="ctr">
+                    <a:lnL w="12700" cap="flat" cmpd="sng" algn="ctr">
+                      <a:solidFill>
+                        <a:srgbClr val="E1E4E9"/>
+                      </a:solidFill>
+                      <a:prstDash val="solid"/>
+                      <a:round/>
+                      <a:headEnd type="none" w="med" len="med"/>
+                      <a:tailEnd type="none" w="med" len="med"/>
+                    </a:lnL>
+                    <a:lnR w="12700" cap="flat" cmpd="sng" algn="ctr">
+                      <a:solidFill>
+                        <a:srgbClr val="E1E4E9"/>
+                      </a:solidFill>
+                      <a:prstDash val="solid"/>
+                      <a:round/>
+                      <a:headEnd type="none" w="med" len="med"/>
+                      <a:tailEnd type="none" w="med" len="med"/>
+                    </a:lnR>
+                    <a:lnT w="12700" cap="flat" cmpd="sng" algn="ctr">
+                      <a:solidFill>
+                        <a:srgbClr val="E1E4E9"/>
+                      </a:solidFill>
+                      <a:prstDash val="solid"/>
+                      <a:round/>
+                      <a:headEnd type="none" w="med" len="med"/>
+                      <a:tailEnd type="none" w="med" len="med"/>
+                    </a:lnT>
+                    <a:lnB w="12700" cap="flat" cmpd="sng" algn="ctr">
+                      <a:solidFill>
+                        <a:srgbClr val="E1E4E9"/>
+                      </a:solidFill>
+                      <a:prstDash val="solid"/>
+                      <a:round/>
+                      <a:headEnd type="none" w="med" len="med"/>
+                      <a:tailEnd type="none" w="med" len="med"/>
+                    </a:lnB>
+                    <a:solidFill>
+                      <a:srgbClr val="FFFFFF"/>
+                    </a:solidFill>
+                  </a:tcPr>
+                </a:tc>
+                <a:tc>
+                  <a:txBody>
+                    <a:bodyPr/>
+                    <a:lstStyle/>
+                    <a:p>
+                      <a:pPr indent="0" marL="0">
+                        <a:buNone/>
+                      </a:pPr>
+                      <a:r>
+                        <a:rPr lang="en-US" sz="1100" dirty="0">
+                          <a:solidFill>
+                            <a:srgbClr val="15181F"/>
+                          </a:solidFill>
+                          <a:latin typeface="Courier New" pitchFamily="34" charset="0"/>
+                          <a:ea typeface="Courier New" pitchFamily="34" charset="-122"/>
+                          <a:cs typeface="Courier New" pitchFamily="34" charset="-120"/>
+                        </a:rPr>
+                        <a:t>headers: Content-Type</a:t>
+                      </a:r>
+                      <a:endParaRPr lang="en-US" sz="1100" dirty="0">
+                        <a:latin typeface="Courier New" charset="0"/>
+                        <a:ea typeface="Courier New" charset="0"/>
+                        <a:cs typeface="Courier New" charset="0"/>
+                      </a:endParaRPr>
+                    </a:p>
+                  </a:txBody>
+                  <a:tcPr marL="91440" marR="91440" marT="45720" marB="45720" anchor="ctr">
+                    <a:lnL w="12700" cap="flat" cmpd="sng" algn="ctr">
+                      <a:solidFill>
+                        <a:srgbClr val="E1E4E9"/>
+                      </a:solidFill>
+                      <a:prstDash val="solid"/>
+                      <a:round/>
+                      <a:headEnd type="none" w="med" len="med"/>
+                      <a:tailEnd type="none" w="med" len="med"/>
+                    </a:lnL>
+                    <a:lnR w="12700" cap="flat" cmpd="sng" algn="ctr">
+                      <a:solidFill>
+                        <a:srgbClr val="E1E4E9"/>
+                      </a:solidFill>
+                      <a:prstDash val="solid"/>
+                      <a:round/>
+                      <a:headEnd type="none" w="med" len="med"/>
+                      <a:tailEnd type="none" w="med" len="med"/>
+                    </a:lnR>
+                    <a:lnT w="12700" cap="flat" cmpd="sng" algn="ctr">
+                      <a:solidFill>
+                        <a:srgbClr val="E1E4E9"/>
+                      </a:solidFill>
+                      <a:prstDash val="solid"/>
+                      <a:round/>
+                      <a:headEnd type="none" w="med" len="med"/>
+                      <a:tailEnd type="none" w="med" len="med"/>
+                    </a:lnT>
+                    <a:lnB w="12700" cap="flat" cmpd="sng" algn="ctr">
+                      <a:solidFill>
+                        <a:srgbClr val="E1E4E9"/>
+                      </a:solidFill>
+                      <a:prstDash val="solid"/>
+                      <a:round/>
+                      <a:headEnd type="none" w="med" len="med"/>
+                      <a:tailEnd type="none" w="med" len="med"/>
+                    </a:lnB>
+                    <a:solidFill>
+                      <a:srgbClr val="FFFFFF"/>
+                    </a:solidFill>
+                  </a:tcPr>
+                </a:tc>
+                <a:tc>
+                  <a:txBody>
+                    <a:bodyPr/>
+                    <a:lstStyle/>
+                    <a:p>
+                      <a:pPr indent="0" marL="0">
+                        <a:buNone/>
+                      </a:pPr>
+                      <a:r>
+                        <a:rPr lang="en-US" sz="1100" dirty="0">
+                          <a:solidFill>
+                            <a:srgbClr val="15181F"/>
+                          </a:solidFill>
+                          <a:latin typeface="Courier New" pitchFamily="34" charset="0"/>
+                          <a:ea typeface="Courier New" pitchFamily="34" charset="-122"/>
+                          <a:cs typeface="Courier New" pitchFamily="34" charset="-120"/>
+                        </a:rPr>
+                        <a:t>declare it as JSON</a:t>
+                      </a:r>
+                      <a:endParaRPr lang="en-US" sz="1100" dirty="0">
+                        <a:latin typeface="Courier New" charset="0"/>
+                        <a:ea typeface="Courier New" charset="0"/>
+                        <a:cs typeface="Courier New" charset="0"/>
+                      </a:endParaRPr>
+                    </a:p>
+                  </a:txBody>
+                  <a:tcPr marL="91440" marR="91440" marT="45720" marB="45720" anchor="ctr">
+                    <a:lnL w="12700" cap="flat" cmpd="sng" algn="ctr">
+                      <a:solidFill>
+                        <a:srgbClr val="E1E4E9"/>
+                      </a:solidFill>
+                      <a:prstDash val="solid"/>
+                      <a:round/>
+                      <a:headEnd type="none" w="med" len="med"/>
+                      <a:tailEnd type="none" w="med" len="med"/>
+                    </a:lnL>
+                    <a:lnR w="12700" cap="flat" cmpd="sng" algn="ctr">
+                      <a:solidFill>
+                        <a:srgbClr val="E1E4E9"/>
+                      </a:solidFill>
+                      <a:prstDash val="solid"/>
+                      <a:round/>
+                      <a:headEnd type="none" w="med" len="med"/>
+                      <a:tailEnd type="none" w="med" len="med"/>
+                    </a:lnR>
+                    <a:lnT w="12700" cap="flat" cmpd="sng" algn="ctr">
+                      <a:solidFill>
+                        <a:srgbClr val="E1E4E9"/>
+                      </a:solidFill>
+                      <a:prstDash val="solid"/>
+                      <a:round/>
+                      <a:headEnd type="none" w="med" len="med"/>
+                      <a:tailEnd type="none" w="med" len="med"/>
+                    </a:lnT>
+                    <a:lnB w="12700" cap="flat" cmpd="sng" algn="ctr">
+                      <a:solidFill>
+                        <a:srgbClr val="E1E4E9"/>
+                      </a:solidFill>
+                      <a:prstDash val="solid"/>
+                      <a:round/>
+                      <a:headEnd type="none" w="med" len="med"/>
+                      <a:tailEnd type="none" w="med" len="med"/>
+                    </a:lnB>
+                    <a:solidFill>
+                      <a:srgbClr val="FFFFFF"/>
+                    </a:solidFill>
+                  </a:tcPr>
+                </a:tc>
+              </a:tr>
+              <a:tr h="713232">
+                <a:tc>
+                  <a:txBody>
+                    <a:bodyPr/>
+                    <a:lstStyle/>
+                    <a:p>
+                      <a:pPr indent="0" marL="0">
+                        <a:buNone/>
+                      </a:pPr>
+                      <a:r>
+                        <a:rPr lang="en-US" sz="1100" dirty="0">
+                          <a:solidFill>
+                            <a:srgbClr val="15181F"/>
+                          </a:solidFill>
+                          <a:latin typeface="Courier New" pitchFamily="34" charset="0"/>
+                          <a:ea typeface="Courier New" pitchFamily="34" charset="-122"/>
+                          <a:cs typeface="Courier New" pitchFamily="34" charset="-120"/>
+                        </a:rPr>
+                        <a:t>String body = ...</a:t>
+                      </a:r>
+                      <a:endParaRPr lang="en-US" sz="1100" dirty="0">
+                        <a:latin typeface="Courier New" charset="0"/>
+                        <a:ea typeface="Courier New" charset="0"/>
+                        <a:cs typeface="Courier New" charset="0"/>
+                      </a:endParaRPr>
+                    </a:p>
+                  </a:txBody>
+                  <a:tcPr marL="91440" marR="91440" marT="45720" marB="45720" anchor="ctr">
+                    <a:lnL w="12700" cap="flat" cmpd="sng" algn="ctr">
+                      <a:solidFill>
+                        <a:srgbClr val="E1E4E9"/>
+                      </a:solidFill>
+                      <a:prstDash val="solid"/>
+                      <a:round/>
+                      <a:headEnd type="none" w="med" len="med"/>
+                      <a:tailEnd type="none" w="med" len="med"/>
+                    </a:lnL>
+                    <a:lnR w="12700" cap="flat" cmpd="sng" algn="ctr">
+                      <a:solidFill>
+                        <a:srgbClr val="E1E4E9"/>
+                      </a:solidFill>
+                      <a:prstDash val="solid"/>
+                      <a:round/>
+                      <a:headEnd type="none" w="med" len="med"/>
+                      <a:tailEnd type="none" w="med" len="med"/>
+                    </a:lnR>
+                    <a:lnT w="12700" cap="flat" cmpd="sng" algn="ctr">
+                      <a:solidFill>
+                        <a:srgbClr val="E1E4E9"/>
+                      </a:solidFill>
+                      <a:prstDash val="solid"/>
+                      <a:round/>
+                      <a:headEnd type="none" w="med" len="med"/>
+                      <a:tailEnd type="none" w="med" len="med"/>
+                    </a:lnT>
+                    <a:lnB w="12700" cap="flat" cmpd="sng" algn="ctr">
+                      <a:solidFill>
+                        <a:srgbClr val="E1E4E9"/>
+                      </a:solidFill>
+                      <a:prstDash val="solid"/>
+                      <a:round/>
+                      <a:headEnd type="none" w="med" len="med"/>
+                      <a:tailEnd type="none" w="med" len="med"/>
+                    </a:lnB>
+                    <a:solidFill>
+                      <a:srgbClr val="FFFFFF"/>
+                    </a:solidFill>
+                  </a:tcPr>
+                </a:tc>
+                <a:tc>
+                  <a:txBody>
+                    <a:bodyPr/>
+                    <a:lstStyle/>
+                    <a:p>
+                      <a:pPr indent="0" marL="0">
+                        <a:buNone/>
+                      </a:pPr>
+                      <a:r>
+                        <a:rPr lang="en-US" sz="1100" dirty="0">
+                          <a:solidFill>
+                            <a:srgbClr val="15181F"/>
+                          </a:solidFill>
+                          <a:latin typeface="Courier New" pitchFamily="34" charset="0"/>
+                          <a:ea typeface="Courier New" pitchFamily="34" charset="-122"/>
+                          <a:cs typeface="Courier New" pitchFamily="34" charset="-120"/>
+                        </a:rPr>
+                        <a:t>body: JSON.stringify(...)</a:t>
+                      </a:r>
+                      <a:endParaRPr lang="en-US" sz="1100" dirty="0">
+                        <a:latin typeface="Courier New" charset="0"/>
+                        <a:ea typeface="Courier New" charset="0"/>
+                        <a:cs typeface="Courier New" charset="0"/>
+                      </a:endParaRPr>
+                    </a:p>
+                  </a:txBody>
+                  <a:tcPr marL="91440" marR="91440" marT="45720" marB="45720" anchor="ctr">
+                    <a:lnL w="12700" cap="flat" cmpd="sng" algn="ctr">
+                      <a:solidFill>
+                        <a:srgbClr val="E1E4E9"/>
+                      </a:solidFill>
+                      <a:prstDash val="solid"/>
+                      <a:round/>
+                      <a:headEnd type="none" w="med" len="med"/>
+                      <a:tailEnd type="none" w="med" len="med"/>
+                    </a:lnL>
+                    <a:lnR w="12700" cap="flat" cmpd="sng" algn="ctr">
+                      <a:solidFill>
+                        <a:srgbClr val="E1E4E9"/>
+                      </a:solidFill>
+                      <a:prstDash val="solid"/>
+                      <a:round/>
+                      <a:headEnd type="none" w="med" len="med"/>
+                      <a:tailEnd type="none" w="med" len="med"/>
+                    </a:lnR>
+                    <a:lnT w="12700" cap="flat" cmpd="sng" algn="ctr">
+                      <a:solidFill>
+                        <a:srgbClr val="E1E4E9"/>
+                      </a:solidFill>
+                      <a:prstDash val="solid"/>
+                      <a:round/>
+                      <a:headEnd type="none" w="med" len="med"/>
+                      <a:tailEnd type="none" w="med" len="med"/>
+                    </a:lnT>
+                    <a:lnB w="12700" cap="flat" cmpd="sng" algn="ctr">
+                      <a:solidFill>
+                        <a:srgbClr val="E1E4E9"/>
+                      </a:solidFill>
+                      <a:prstDash val="solid"/>
+                      <a:round/>
+                      <a:headEnd type="none" w="med" len="med"/>
+                      <a:tailEnd type="none" w="med" len="med"/>
+                    </a:lnB>
+                    <a:solidFill>
+                      <a:srgbClr val="FFFFFF"/>
+                    </a:solidFill>
+                  </a:tcPr>
+                </a:tc>
+                <a:tc>
+                  <a:txBody>
+                    <a:bodyPr/>
+                    <a:lstStyle/>
+                    <a:p>
+                      <a:pPr indent="0" marL="0">
+                        <a:buNone/>
+                      </a:pPr>
+                      <a:r>
+                        <a:rPr lang="en-US" sz="1100" dirty="0">
+                          <a:solidFill>
+                            <a:srgbClr val="15181F"/>
+                          </a:solidFill>
+                          <a:latin typeface="Courier New" pitchFamily="34" charset="0"/>
+                          <a:ea typeface="Courier New" pitchFamily="34" charset="-122"/>
+                          <a:cs typeface="Courier New" pitchFamily="34" charset="-120"/>
+                        </a:rPr>
+                        <a:t>build the data</a:t>
+                      </a:r>
+                      <a:endParaRPr lang="en-US" sz="1100" dirty="0">
+                        <a:latin typeface="Courier New" charset="0"/>
+                        <a:ea typeface="Courier New" charset="0"/>
+                        <a:cs typeface="Courier New" charset="0"/>
+                      </a:endParaRPr>
+                    </a:p>
+                  </a:txBody>
+                  <a:tcPr marL="91440" marR="91440" marT="45720" marB="45720" anchor="ctr">
+                    <a:lnL w="12700" cap="flat" cmpd="sng" algn="ctr">
+                      <a:solidFill>
+                        <a:srgbClr val="E1E4E9"/>
+                      </a:solidFill>
+                      <a:prstDash val="solid"/>
+                      <a:round/>
+                      <a:headEnd type="none" w="med" len="med"/>
+                      <a:tailEnd type="none" w="med" len="med"/>
+                    </a:lnL>
+                    <a:lnR w="12700" cap="flat" cmpd="sng" algn="ctr">
+                      <a:solidFill>
+                        <a:srgbClr val="E1E4E9"/>
+                      </a:solidFill>
+                      <a:prstDash val="solid"/>
+                      <a:round/>
+                      <a:headEnd type="none" w="med" len="med"/>
+                      <a:tailEnd type="none" w="med" len="med"/>
+                    </a:lnR>
+                    <a:lnT w="12700" cap="flat" cmpd="sng" algn="ctr">
+                      <a:solidFill>
+                        <a:srgbClr val="E1E4E9"/>
+                      </a:solidFill>
+                      <a:prstDash val="solid"/>
+                      <a:round/>
+                      <a:headEnd type="none" w="med" len="med"/>
+                      <a:tailEnd type="none" w="med" len="med"/>
+                    </a:lnT>
+                    <a:lnB w="12700" cap="flat" cmpd="sng" algn="ctr">
+                      <a:solidFill>
+                        <a:srgbClr val="E1E4E9"/>
+                      </a:solidFill>
+                      <a:prstDash val="solid"/>
+                      <a:round/>
+                      <a:headEnd type="none" w="med" len="med"/>
+                      <a:tailEnd type="none" w="med" len="med"/>
+                    </a:lnB>
+                    <a:solidFill>
+                      <a:srgbClr val="FFFFFF"/>
+                    </a:solidFill>
+                  </a:tcPr>
+                </a:tc>
+              </a:tr>
+              <a:tr h="713232">
+                <a:tc>
+                  <a:txBody>
+                    <a:bodyPr/>
+                    <a:lstStyle/>
+                    <a:p>
+                      <a:pPr indent="0" marL="0">
+                        <a:buNone/>
+                      </a:pPr>
+                      <a:r>
+                        <a:rPr lang="en-US" sz="1100" dirty="0">
+                          <a:solidFill>
+                            <a:srgbClr val="15181F"/>
+                          </a:solidFill>
+                          <a:latin typeface="Courier New" pitchFamily="34" charset="0"/>
+                          <a:ea typeface="Courier New" pitchFamily="34" charset="-122"/>
+                          <a:cs typeface="Courier New" pitchFamily="34" charset="-120"/>
+                        </a:rPr>
+                        <a:t>http.POST(body)</a:t>
+                      </a:r>
+                      <a:endParaRPr lang="en-US" sz="1100" dirty="0">
+                        <a:latin typeface="Courier New" charset="0"/>
+                        <a:ea typeface="Courier New" charset="0"/>
+                        <a:cs typeface="Courier New" charset="0"/>
+                      </a:endParaRPr>
+                    </a:p>
+                  </a:txBody>
+                  <a:tcPr marL="91440" marR="91440" marT="45720" marB="45720" anchor="ctr">
+                    <a:lnL w="12700" cap="flat" cmpd="sng" algn="ctr">
+                      <a:solidFill>
+                        <a:srgbClr val="E1E4E9"/>
+                      </a:solidFill>
+                      <a:prstDash val="solid"/>
+                      <a:round/>
+                      <a:headEnd type="none" w="med" len="med"/>
+                      <a:tailEnd type="none" w="med" len="med"/>
+                    </a:lnL>
+                    <a:lnR w="12700" cap="flat" cmpd="sng" algn="ctr">
+                      <a:solidFill>
+                        <a:srgbClr val="E1E4E9"/>
+                      </a:solidFill>
+                      <a:prstDash val="solid"/>
+                      <a:round/>
+                      <a:headEnd type="none" w="med" len="med"/>
+                      <a:tailEnd type="none" w="med" len="med"/>
+                    </a:lnR>
+                    <a:lnT w="12700" cap="flat" cmpd="sng" algn="ctr">
+                      <a:solidFill>
+                        <a:srgbClr val="E1E4E9"/>
+                      </a:solidFill>
+                      <a:prstDash val="solid"/>
+                      <a:round/>
+                      <a:headEnd type="none" w="med" len="med"/>
+                      <a:tailEnd type="none" w="med" len="med"/>
+                    </a:lnT>
+                    <a:lnB w="12700" cap="flat" cmpd="sng" algn="ctr">
+                      <a:solidFill>
+                        <a:srgbClr val="E1E4E9"/>
+                      </a:solidFill>
+                      <a:prstDash val="solid"/>
+                      <a:round/>
+                      <a:headEnd type="none" w="med" len="med"/>
+                      <a:tailEnd type="none" w="med" len="med"/>
+                    </a:lnB>
+                    <a:solidFill>
+                      <a:srgbClr val="FFFFFF"/>
+                    </a:solidFill>
+                  </a:tcPr>
+                </a:tc>
+                <a:tc>
+                  <a:txBody>
+                    <a:bodyPr/>
+                    <a:lstStyle/>
+                    <a:p>
+                      <a:pPr indent="0" marL="0">
+                        <a:buNone/>
+                      </a:pPr>
+                      <a:r>
+                        <a:rPr lang="en-US" sz="1100" dirty="0">
+                          <a:solidFill>
+                            <a:srgbClr val="15181F"/>
+                          </a:solidFill>
+                          <a:latin typeface="Courier New" pitchFamily="34" charset="0"/>
+                          <a:ea typeface="Courier New" pitchFamily="34" charset="-122"/>
+                          <a:cs typeface="Courier New" pitchFamily="34" charset="-120"/>
+                        </a:rPr>
+                        <a:t>method: POST</a:t>
+                      </a:r>
+                      <a:endParaRPr lang="en-US" sz="1100" dirty="0">
+                        <a:latin typeface="Courier New" charset="0"/>
+                        <a:ea typeface="Courier New" charset="0"/>
+                        <a:cs typeface="Courier New" charset="0"/>
+                      </a:endParaRPr>
+                    </a:p>
+                  </a:txBody>
+                  <a:tcPr marL="91440" marR="91440" marT="45720" marB="45720" anchor="ctr">
+                    <a:lnL w="12700" cap="flat" cmpd="sng" algn="ctr">
+                      <a:solidFill>
+                        <a:srgbClr val="E1E4E9"/>
+                      </a:solidFill>
+                      <a:prstDash val="solid"/>
+                      <a:round/>
+                      <a:headEnd type="none" w="med" len="med"/>
+                      <a:tailEnd type="none" w="med" len="med"/>
+                    </a:lnL>
+                    <a:lnR w="12700" cap="flat" cmpd="sng" algn="ctr">
+                      <a:solidFill>
+                        <a:srgbClr val="E1E4E9"/>
+                      </a:solidFill>
+                      <a:prstDash val="solid"/>
+                      <a:round/>
+                      <a:headEnd type="none" w="med" len="med"/>
+                      <a:tailEnd type="none" w="med" len="med"/>
+                    </a:lnR>
+                    <a:lnT w="12700" cap="flat" cmpd="sng" algn="ctr">
+                      <a:solidFill>
+                        <a:srgbClr val="E1E4E9"/>
+                      </a:solidFill>
+                      <a:prstDash val="solid"/>
+                      <a:round/>
+                      <a:headEnd type="none" w="med" len="med"/>
+                      <a:tailEnd type="none" w="med" len="med"/>
+                    </a:lnT>
+                    <a:lnB w="12700" cap="flat" cmpd="sng" algn="ctr">
+                      <a:solidFill>
+                        <a:srgbClr val="E1E4E9"/>
+                      </a:solidFill>
+                      <a:prstDash val="solid"/>
+                      <a:round/>
+                      <a:headEnd type="none" w="med" len="med"/>
+                      <a:tailEnd type="none" w="med" len="med"/>
+                    </a:lnB>
+                    <a:solidFill>
+                      <a:srgbClr val="FFFFFF"/>
+                    </a:solidFill>
+                  </a:tcPr>
+                </a:tc>
+                <a:tc>
+                  <a:txBody>
+                    <a:bodyPr/>
+                    <a:lstStyle/>
+                    <a:p>
+                      <a:pPr indent="0" marL="0">
+                        <a:buNone/>
+                      </a:pPr>
+                      <a:r>
+                        <a:rPr lang="en-US" sz="1100" dirty="0">
+                          <a:solidFill>
+                            <a:srgbClr val="15181F"/>
+                          </a:solidFill>
+                          <a:latin typeface="Courier New" pitchFamily="34" charset="0"/>
+                          <a:ea typeface="Courier New" pitchFamily="34" charset="-122"/>
+                          <a:cs typeface="Courier New" pitchFamily="34" charset="-120"/>
+                        </a:rPr>
+                        <a:t>send it</a:t>
+                      </a:r>
+                      <a:endParaRPr lang="en-US" sz="1100" dirty="0">
+                        <a:latin typeface="Courier New" charset="0"/>
+                        <a:ea typeface="Courier New" charset="0"/>
+                        <a:cs typeface="Courier New" charset="0"/>
+                      </a:endParaRPr>
+                    </a:p>
+                  </a:txBody>
+                  <a:tcPr marL="91440" marR="91440" marT="45720" marB="45720" anchor="ctr">
+                    <a:lnL w="12700" cap="flat" cmpd="sng" algn="ctr">
+                      <a:solidFill>
+                        <a:srgbClr val="E1E4E9"/>
+                      </a:solidFill>
+                      <a:prstDash val="solid"/>
+                      <a:round/>
+                      <a:headEnd type="none" w="med" len="med"/>
+                      <a:tailEnd type="none" w="med" len="med"/>
+                    </a:lnL>
+                    <a:lnR w="12700" cap="flat" cmpd="sng" algn="ctr">
+                      <a:solidFill>
+                        <a:srgbClr val="E1E4E9"/>
+                      </a:solidFill>
+                      <a:prstDash val="solid"/>
+                      <a:round/>
+                      <a:headEnd type="none" w="med" len="med"/>
+                      <a:tailEnd type="none" w="med" len="med"/>
+                    </a:lnR>
+                    <a:lnT w="12700" cap="flat" cmpd="sng" algn="ctr">
+                      <a:solidFill>
+                        <a:srgbClr val="E1E4E9"/>
+                      </a:solidFill>
+                      <a:prstDash val="solid"/>
+                      <a:round/>
+                      <a:headEnd type="none" w="med" len="med"/>
+                      <a:tailEnd type="none" w="med" len="med"/>
+                    </a:lnT>
+                    <a:lnB w="12700" cap="flat" cmpd="sng" algn="ctr">
+                      <a:solidFill>
+                        <a:srgbClr val="E1E4E9"/>
+                      </a:solidFill>
+                      <a:prstDash val="solid"/>
+                      <a:round/>
+                      <a:headEnd type="none" w="med" len="med"/>
+                      <a:tailEnd type="none" w="med" len="med"/>
+                    </a:lnB>
+                    <a:solidFill>
+                      <a:srgbClr val="FFFFFF"/>
+                    </a:solidFill>
+                  </a:tcPr>
+                </a:tc>
+              </a:tr>
+            </a:tbl>
+          </a:graphicData>
+        </a:graphic>
+      </p:graphicFrame>
+      <p:sp>
+        <p:nvSpPr>
+          <p:cNvPr id="5" name="Shape 2"/>
+          <p:cNvSpPr/>
+          <p:nvPr/>
+        </p:nvSpPr>
+        <p:spPr>
+          <a:xfrm>
+            <a:off x="777240" y="5486400"/>
+            <a:ext cx="10634472" cy="1005840"/>
           </a:xfrm>
           <a:prstGeom prst="roundRect">
             <a:avLst>
-              <a:gd name="adj" fmla="val 2369"/>
+              <a:gd name="adj" fmla="val 8182"/>
             </a:avLst>
           </a:prstGeom>
           <a:solidFill>
-            <a:srgbClr val="1B1F2A"/>
+            <a:srgbClr val="EAF6F3"/>
           </a:solidFill>
           <a:ln w="12700">
             <a:solidFill>
-              <a:srgbClr val="1B1F2A"/>
+              <a:srgbClr val="9CCFC6"/>
             </a:solidFill>
             <a:prstDash val="solid"/>
           </a:ln>
@@ -51773,288 +53002,40 @@
       </p:sp>
       <p:sp>
         <p:nvSpPr>
-          <p:cNvPr id="6" name="Text 4"/>
-          <p:cNvSpPr/>
-          <p:nvPr/>
-        </p:nvSpPr>
-        <p:spPr>
-          <a:xfrm>
-            <a:off x="1069848" y="2148840"/>
-            <a:ext cx="5486400" cy="274320"/>
-          </a:xfrm>
-          <a:prstGeom prst="rect">
-            <a:avLst/>
-          </a:prstGeom>
-          <a:noFill/>
-          <a:ln/>
-        </p:spPr>
-        <p:txBody>
-          <a:bodyPr wrap="square" lIns="0" tIns="0" rIns="0" bIns="0" rtlCol="0" anchor="ctr"/>
-          <a:lstStyle/>
-          <a:p>
-            <a:pPr indent="0" marL="0">
-              <a:buNone/>
-            </a:pPr>
-            <a:r>
-              <a:rPr lang="en-US" sz="1050" b="1" spc="100" kern="0" dirty="0">
-                <a:solidFill>
-                  <a:srgbClr val="8B93A3"/>
-                </a:solidFill>
-                <a:latin typeface="Courier New" pitchFamily="34" charset="0"/>
-                <a:ea typeface="Courier New" pitchFamily="34" charset="-122"/>
-                <a:cs typeface="Courier New" pitchFamily="34" charset="-120"/>
-              </a:rPr>
-              <a:t>ESP32 / Arduino</a:t>
-            </a:r>
-            <a:endParaRPr lang="en-US" sz="1050" dirty="0"/>
-          </a:p>
-        </p:txBody>
-      </p:sp>
-      <p:sp>
-        <p:nvSpPr>
-          <p:cNvPr id="7" name="Text 5"/>
-          <p:cNvSpPr/>
-          <p:nvPr/>
-        </p:nvSpPr>
-        <p:spPr>
-          <a:xfrm>
-            <a:off x="1069848" y="2468880"/>
-            <a:ext cx="10085832" cy="2538730"/>
-          </a:xfrm>
-          <a:prstGeom prst="rect">
-            <a:avLst/>
-          </a:prstGeom>
-          <a:noFill/>
-          <a:ln/>
-        </p:spPr>
-        <p:txBody>
-          <a:bodyPr wrap="square" lIns="0" tIns="0" rIns="0" bIns="0" rtlCol="0" anchor="t"/>
-          <a:lstStyle/>
-          <a:p>
-            <a:pPr indent="0" marL="0">
-              <a:lnSpc>
-                <a:spcPts val="1850"/>
-              </a:lnSpc>
+          <p:cNvPr id="6" name="Text 3"/>
+          <p:cNvSpPr/>
+          <p:nvPr/>
+        </p:nvSpPr>
+        <p:spPr>
+          <a:xfrm>
+            <a:off x="1143000" y="5577840"/>
+            <a:ext cx="10241280" cy="822960"/>
+          </a:xfrm>
+          <a:prstGeom prst="rect">
+            <a:avLst/>
+          </a:prstGeom>
+          <a:noFill/>
+          <a:ln/>
+        </p:spPr>
+        <p:txBody>
+          <a:bodyPr wrap="square" lIns="0" tIns="0" rIns="0" bIns="0" rtlCol="0" anchor="ctr"/>
+          <a:lstStyle/>
+          <a:p>
+            <a:pPr indent="0" marL="0">
               <a:buNone/>
             </a:pPr>
             <a:r>
               <a:rPr lang="en-US" sz="1500" dirty="0">
                 <a:solidFill>
-                  <a:srgbClr val="E6E9EF"/>
-                </a:solidFill>
-                <a:latin typeface="Courier New" pitchFamily="34" charset="0"/>
-                <a:ea typeface="Courier New" pitchFamily="34" charset="-122"/>
-                <a:cs typeface="Courier New" pitchFamily="34" charset="-120"/>
-              </a:rPr>
-              <a:t>WiFiClientSecure client;</a:t>
-            </a:r>
-            <a:endParaRPr lang="en-US" sz="1500" dirty="0"/>
-          </a:p>
-          <a:p>
-            <a:pPr indent="0" marL="0">
-              <a:lnSpc>
-                <a:spcPts val="1850"/>
-              </a:lnSpc>
-              <a:buNone/>
-            </a:pPr>
-            <a:r>
-              <a:rPr lang="en-US" sz="1500" dirty="0">
-                <a:solidFill>
-                  <a:srgbClr val="E6E9EF"/>
-                </a:solidFill>
-                <a:latin typeface="Courier New" pitchFamily="34" charset="0"/>
-                <a:ea typeface="Courier New" pitchFamily="34" charset="-122"/>
-                <a:cs typeface="Courier New" pitchFamily="34" charset="-120"/>
-              </a:rPr>
-              <a:t>client.setInsecure();</a:t>
-            </a:r>
-            <a:endParaRPr lang="en-US" sz="1500" dirty="0"/>
-          </a:p>
-          <a:p>
-            <a:pPr indent="0" marL="0">
-              <a:lnSpc>
-                <a:spcPts val="1850"/>
-              </a:lnSpc>
-              <a:buNone/>
-            </a:pPr>
-            <a:endParaRPr lang="en-US" sz="1500" dirty="0"/>
-          </a:p>
-          <a:p>
-            <a:pPr indent="0" marL="0">
-              <a:lnSpc>
-                <a:spcPts val="1850"/>
-              </a:lnSpc>
-              <a:buNone/>
-            </a:pPr>
-            <a:r>
-              <a:rPr lang="en-US" sz="1500" dirty="0">
-                <a:solidFill>
-                  <a:srgbClr val="E6E9EF"/>
-                </a:solidFill>
-                <a:latin typeface="Courier New" pitchFamily="34" charset="0"/>
-                <a:ea typeface="Courier New" pitchFamily="34" charset="-122"/>
-                <a:cs typeface="Courier New" pitchFamily="34" charset="-120"/>
-              </a:rPr>
-              <a:t>HTTPClient http;</a:t>
-            </a:r>
-            <a:endParaRPr lang="en-US" sz="1500" dirty="0"/>
-          </a:p>
-          <a:p>
-            <a:pPr indent="0" marL="0">
-              <a:lnSpc>
-                <a:spcPts val="1850"/>
-              </a:lnSpc>
-              <a:buNone/>
-            </a:pPr>
-            <a:r>
-              <a:rPr lang="en-US" sz="1500" dirty="0">
-                <a:solidFill>
-                  <a:srgbClr val="E6E9EF"/>
-                </a:solidFill>
-                <a:latin typeface="Courier New" pitchFamily="34" charset="0"/>
-                <a:ea typeface="Courier New" pitchFamily="34" charset="-122"/>
-                <a:cs typeface="Courier New" pitchFamily="34" charset="-120"/>
-              </a:rPr>
-              <a:t>http.begin(client, ENDPOINT);</a:t>
-            </a:r>
-            <a:endParaRPr lang="en-US" sz="1500" dirty="0"/>
-          </a:p>
-          <a:p>
-            <a:pPr indent="0" marL="0">
-              <a:lnSpc>
-                <a:spcPts val="1850"/>
-              </a:lnSpc>
-              <a:buNone/>
-            </a:pPr>
-            <a:r>
-              <a:rPr lang="en-US" sz="1500" dirty="0">
-                <a:solidFill>
-                  <a:srgbClr val="E6E9EF"/>
-                </a:solidFill>
-                <a:latin typeface="Courier New" pitchFamily="34" charset="0"/>
-                <a:ea typeface="Courier New" pitchFamily="34" charset="-122"/>
-                <a:cs typeface="Courier New" pitchFamily="34" charset="-120"/>
-              </a:rPr>
-              <a:t>http.addHeader("Content-Type", "application/json");</a:t>
-            </a:r>
-            <a:endParaRPr lang="en-US" sz="1500" dirty="0"/>
-          </a:p>
-          <a:p>
-            <a:pPr indent="0" marL="0">
-              <a:lnSpc>
-                <a:spcPts val="1850"/>
-              </a:lnSpc>
-              <a:buNone/>
-            </a:pPr>
-            <a:endParaRPr lang="en-US" sz="1500" dirty="0"/>
-          </a:p>
-          <a:p>
-            <a:pPr indent="0" marL="0">
-              <a:lnSpc>
-                <a:spcPts val="1850"/>
-              </a:lnSpc>
-              <a:buNone/>
-            </a:pPr>
-            <a:r>
-              <a:rPr lang="en-US" sz="1500" dirty="0">
-                <a:solidFill>
-                  <a:srgbClr val="E6E9EF"/>
-                </a:solidFill>
-                <a:latin typeface="Courier New" pitchFamily="34" charset="0"/>
-                <a:ea typeface="Courier New" pitchFamily="34" charset="-122"/>
-                <a:cs typeface="Courier New" pitchFamily="34" charset="-120"/>
-              </a:rPr>
-              <a:t>String body = String("{\"sensor\":\"motor_temp\",\"value\":") + reading +</a:t>
-            </a:r>
-            <a:endParaRPr lang="en-US" sz="1500" dirty="0"/>
-          </a:p>
-          <a:p>
-            <a:pPr indent="0" marL="0">
-              <a:lnSpc>
-                <a:spcPts val="1850"/>
-              </a:lnSpc>
-              <a:buNone/>
-            </a:pPr>
-            <a:r>
-              <a:rPr lang="en-US" sz="1500" dirty="0">
-                <a:solidFill>
-                  <a:srgbClr val="E6E9EF"/>
-                </a:solidFill>
-                <a:latin typeface="Courier New" pitchFamily="34" charset="0"/>
-                <a:ea typeface="Courier New" pitchFamily="34" charset="-122"/>
-                <a:cs typeface="Courier New" pitchFamily="34" charset="-120"/>
-              </a:rPr>
-              <a:t>              ",\"unit\":\"C\",\"low\":20,\"high\":60}";</a:t>
-            </a:r>
-            <a:endParaRPr lang="en-US" sz="1500" dirty="0"/>
-          </a:p>
-          <a:p>
-            <a:pPr indent="0" marL="0">
-              <a:lnSpc>
-                <a:spcPts val="1850"/>
-              </a:lnSpc>
-              <a:buNone/>
-            </a:pPr>
-            <a:endParaRPr lang="en-US" sz="1500" dirty="0"/>
-          </a:p>
-          <a:p>
-            <a:pPr indent="0" marL="0">
-              <a:lnSpc>
-                <a:spcPts val="1850"/>
-              </a:lnSpc>
-              <a:buNone/>
-            </a:pPr>
-            <a:r>
-              <a:rPr lang="en-US" sz="1500" dirty="0">
-                <a:solidFill>
-                  <a:srgbClr val="E6E9EF"/>
-                </a:solidFill>
-                <a:latin typeface="Courier New" pitchFamily="34" charset="0"/>
-                <a:ea typeface="Courier New" pitchFamily="34" charset="-122"/>
-                <a:cs typeface="Courier New" pitchFamily="34" charset="-120"/>
-              </a:rPr>
-              <a:t>int status = http.POST(body);</a:t>
-            </a:r>
-            <a:endParaRPr lang="en-US" sz="1500" dirty="0"/>
-          </a:p>
-        </p:txBody>
-      </p:sp>
-      <p:sp>
-        <p:nvSpPr>
-          <p:cNvPr id="8" name="Text 6"/>
-          <p:cNvSpPr/>
-          <p:nvPr/>
-        </p:nvSpPr>
-        <p:spPr>
-          <a:xfrm>
-            <a:off x="777240" y="5349240"/>
-            <a:ext cx="10634472" cy="822960"/>
-          </a:xfrm>
-          <a:prstGeom prst="rect">
-            <a:avLst/>
-          </a:prstGeom>
-          <a:noFill/>
-          <a:ln/>
-        </p:spPr>
-        <p:txBody>
-          <a:bodyPr wrap="square" lIns="0" tIns="0" rIns="0" bIns="0" rtlCol="0" anchor="ctr"/>
-          <a:lstStyle/>
-          <a:p>
-            <a:pPr indent="0" marL="0">
-              <a:buNone/>
-            </a:pPr>
-            <a:r>
-              <a:rPr lang="en-US" sz="1550" dirty="0">
-                <a:solidFill>
-                  <a:srgbClr val="5C6470"/>
+                  <a:srgbClr val="00776A"/>
                 </a:solidFill>
                 <a:latin typeface="Calibri" pitchFamily="34" charset="0"/>
                 <a:ea typeface="Calibri" pitchFamily="34" charset="-122"/>
                 <a:cs typeface="Calibri" pitchFamily="34" charset="-120"/>
               </a:rPr>
-              <a:t>Your /readings endpoint accepts JSON. It does not know or care whether that JSON came from a browser, a phone, a Python script, or a microcontroller.</a:t>
-            </a:r>
-            <a:endParaRPr lang="en-US" sz="1550" dirty="0"/>
+              <a:t>Identical request. No change to your server. The C++ is longer only because a microcontroller has no JSON library, so the text is assembled by hand.</a:t>
+            </a:r>
+            <a:endParaRPr lang="en-US" sz="1500" dirty="0"/>
           </a:p>
         </p:txBody>
       </p:sp>

</xml_diff>